<commit_message>
Final copies: report layout pass, balanced paper columns, 20-slide presentation
</commit_message>
<xml_diff>
--- a/docs/presentation/ScamGuard_PP2_Presentation.pptx
+++ b/docs/presentation/ScamGuard_PP2_Presentation.pptx
@@ -23,15 +23,10 @@
     <p:sldId id="279" r:id="rId27"/>
     <p:sldId id="280" r:id="rId28"/>
     <p:sldId id="281" r:id="rId29"/>
-    <p:sldId id="282" r:id="rId30"/>
-    <p:sldId id="283" r:id="rId31"/>
-    <p:sldId id="284" r:id="rId32"/>
-    <p:sldId id="285" r:id="rId33"/>
     <p:sldId id="271" r:id="rId12"/>
     <p:sldId id="270" r:id="rId13"/>
     <p:sldId id="272" r:id="rId14"/>
     <p:sldId id="273" r:id="rId15"/>
-    <p:sldId id="286" r:id="rId34"/>
     <p:sldId id="264" r:id="rId16"/>
   </p:sldIdLst>
   <p:sldSz cx="12192000" cy="6858000"/>
@@ -6153,15 +6148,15 @@
             <a:pPr indent="-457200" marL="457200">
               <a:buNone/>
               <a:spcBef>
-                <a:spcPts val="800"/>
+                <a:spcPts val="500"/>
               </a:spcBef>
             </a:pPr>
             <a:r>
-              <a:rPr sz="1500">
-                <a:latin typeface="Times New Roman"/>
-                <a:cs typeface="Times New Roman"/>
-              </a:rPr>
-              <a:t>[1]  S. Agarwal, A. Papasavva, G. Suarez-Tangil, and M. Vasek, "Fishing for smishing: Understanding SMS phishing infrastructure and strategies by mining public user reports," in Proc. ACM Internet Measurement Conf. (IMC), 2025, doi: 10.1145/3730567.3764431.</a:t>
+              <a:rPr sz="1300">
+                <a:latin typeface="Times New Roman"/>
+                <a:cs typeface="Times New Roman"/>
+              </a:rPr>
+              <a:t>[1]  S. Agarwal, A. Papasavva, G. Suarez-Tangil, and M. Vasek, "Fishing for smishing: Understanding SMS phishing infrastructure and strategies by mining public user reports," in Proc. ACM IMC, 2025, doi: 10.1145/3730567.3764431.</a:t>
             </a:r>
             <a:endParaRPr lang="en-IN"/>
           </a:p>
@@ -6169,26 +6164,26 @@
             <a:pPr indent="-457200" marL="457200">
               <a:buNone/>
               <a:spcBef>
-                <a:spcPts val="800"/>
+                <a:spcPts val="500"/>
               </a:spcBef>
             </a:pPr>
             <a:r>
-              <a:rPr sz="1500">
-                <a:latin typeface="Times New Roman"/>
-                <a:cs typeface="Times New Roman"/>
-              </a:rPr>
-              <a:t>[2]  S. Agarwal, G. Suarez-Tangil, and M. Vasek, "An overview of 7726 user reports: Uncovering SMS scams and scammer strategies," in Proc. NDSS Symp., 2026, arXiv:2508.05276.</a:t>
+              <a:rPr sz="1300">
+                <a:latin typeface="Times New Roman"/>
+                <a:cs typeface="Times New Roman"/>
+              </a:rPr>
+              <a:t>[2]  S. Agarwal, G. Suarez-Tangil, and M. Vasek, "An overview of 7726 user reports: Uncovering SMS scams and scammer strategies," in Proc. NDSS Symp., 2026.</a:t>
             </a:r>
           </a:p>
           <a:p>
             <a:pPr indent="-457200" marL="457200">
               <a:buNone/>
               <a:spcBef>
-                <a:spcPts val="800"/>
+                <a:spcPts val="500"/>
               </a:spcBef>
             </a:pPr>
             <a:r>
-              <a:rPr sz="1500">
+              <a:rPr sz="1300">
                 <a:latin typeface="Times New Roman"/>
                 <a:cs typeface="Times New Roman"/>
               </a:rPr>
@@ -6199,26 +6194,26 @@
             <a:pPr indent="-457200" marL="457200">
               <a:buNone/>
               <a:spcBef>
-                <a:spcPts val="800"/>
+                <a:spcPts val="500"/>
               </a:spcBef>
             </a:pPr>
             <a:r>
-              <a:rPr sz="1500">
-                <a:latin typeface="Times New Roman"/>
-                <a:cs typeface="Times New Roman"/>
-              </a:rPr>
-              <a:t>[4]  D. Timko and M. L. Rahman, "Smishing Dataset I: Phishing SMS dataset from Smishtank.com," in Proc. ACM CODASPY, 2024, doi: 10.1145/3626232.3653282.</a:t>
+              <a:rPr sz="1300">
+                <a:latin typeface="Times New Roman"/>
+                <a:cs typeface="Times New Roman"/>
+              </a:rPr>
+              <a:t>[4]  D. Timko and M. L. Rahman, "Smishing Dataset I: Phishing SMS dataset from Smishtank.com," in Proc. ACM CODASPY, 2024.</a:t>
             </a:r>
           </a:p>
           <a:p>
             <a:pPr indent="-457200" marL="457200">
               <a:buNone/>
               <a:spcBef>
-                <a:spcPts val="800"/>
+                <a:spcPts val="500"/>
               </a:spcBef>
             </a:pPr>
             <a:r>
-              <a:rPr sz="1500">
+              <a:rPr sz="1300">
                 <a:latin typeface="Times New Roman"/>
                 <a:cs typeface="Times New Roman"/>
               </a:rPr>
@@ -6229,15 +6224,75 @@
             <a:pPr indent="-457200" marL="457200">
               <a:buNone/>
               <a:spcBef>
-                <a:spcPts val="800"/>
+                <a:spcPts val="500"/>
               </a:spcBef>
             </a:pPr>
             <a:r>
-              <a:rPr sz="1500">
+              <a:rPr sz="1300">
                 <a:latin typeface="Times New Roman"/>
                 <a:cs typeface="Times New Roman"/>
               </a:rPr>
               <a:t>[6]  C. Northcutt, L. Jiang, and I. Chuang, "Confident learning: Estimating uncertainty in dataset labels," J. Artif. Intell. Res., vol. 70, pp. 1373-1411, 2021.</a:t>
+            </a:r>
+          </a:p>
+          <a:p>
+            <a:pPr indent="-457200" marL="457200">
+              <a:buNone/>
+              <a:spcBef>
+                <a:spcPts val="500"/>
+              </a:spcBef>
+            </a:pPr>
+            <a:r>
+              <a:rPr sz="1300">
+                <a:latin typeface="Times New Roman"/>
+                <a:cs typeface="Times New Roman"/>
+              </a:rPr>
+              <a:t>[7]  K. Lee et al., "Deduplicating training data makes language models better," in Proc. ACL, 2022, pp. 8424-8445.</a:t>
+            </a:r>
+          </a:p>
+          <a:p>
+            <a:pPr indent="-457200" marL="457200">
+              <a:buNone/>
+              <a:spcBef>
+                <a:spcPts val="500"/>
+              </a:spcBef>
+            </a:pPr>
+            <a:r>
+              <a:rPr sz="1300">
+                <a:latin typeface="Times New Roman"/>
+                <a:cs typeface="Times New Roman"/>
+              </a:rPr>
+              <a:t>[8]  S. Kapoor and A. Narayanan, "Leakage and the reproducibility crisis in machine-learning-based science," Patterns, 2023.</a:t>
+            </a:r>
+          </a:p>
+          <a:p>
+            <a:pPr indent="-457200" marL="457200">
+              <a:buNone/>
+              <a:spcBef>
+                <a:spcPts val="500"/>
+              </a:spcBef>
+            </a:pPr>
+            <a:r>
+              <a:rPr sz="1300">
+                <a:latin typeface="Times New Roman"/>
+                <a:cs typeface="Times New Roman"/>
+              </a:rPr>
+              <a:t>[9]  A. Z. Broder, "On the resemblance and containment of documents," in Proc. Compression and Complexity of SEQUENCES, 1997.</a:t>
+            </a:r>
+          </a:p>
+          <a:p>
+            <a:pPr indent="-457200" marL="457200">
+              <a:buNone/>
+              <a:spcBef>
+                <a:spcPts val="500"/>
+              </a:spcBef>
+            </a:pPr>
+            <a:r>
+              <a:rPr sz="1300">
+                <a:latin typeface="Times New Roman"/>
+                <a:cs typeface="Times New Roman"/>
+              </a:rPr>
+              <a:t>[10]  G. Salton and C. Buckley, "Term-weighting approaches in automatic text retrieval," Inf. Process. Manage., vol. 24, no. 5, pp. 513-523, 1988.</a:t>
             </a:r>
           </a:p>
         </p:txBody>
@@ -9194,7 +9249,7 @@
                 <a:latin typeface="Times New Roman"/>
                 <a:cs typeface="Times New Roman"/>
               </a:rPr>
-              <a:t>Results: Model Comparison</a:t>
+              <a:t>Results: Model Comparison and Errors</a:t>
             </a:r>
           </a:p>
         </p:txBody>
@@ -9743,7 +9798,7 @@
         <p:spPr>
           <a:xfrm>
             <a:off x="838200" y="3900000"/>
-            <a:ext cx="5000000" cy="2200000"/>
+            <a:ext cx="5000000" cy="2300000"/>
           </a:xfrm>
           <a:prstGeom prst="rect">
             <a:avLst/>
@@ -9758,38 +9813,68 @@
           <a:p>
             <a:pPr marL="228600" indent="-228600">
               <a:spcBef>
-                <a:spcPts val="500"/>
+                <a:spcPts val="400"/>
               </a:spcBef>
               <a:buChar char="•"/>
             </a:pPr>
             <a:r>
-              <a:rPr sz="1600">
-                <a:latin typeface="Times New Roman"/>
-                <a:cs typeface="Times New Roman"/>
-              </a:rPr>
-              <a:t>Logistic regression selected: lowest false-alarm rate among the strong models and readable word weights</a:t>
+              <a:rPr sz="1500">
+                <a:latin typeface="Times New Roman"/>
+                <a:cs typeface="Times New Roman"/>
+              </a:rPr>
+              <a:t>Logistic regression selected: lowest false-alarm rate among the strong models, readable word weights</a:t>
             </a:r>
           </a:p>
           <a:p>
             <a:pPr marL="228600" indent="-228600">
               <a:spcBef>
-                <a:spcPts val="500"/>
+                <a:spcPts val="400"/>
               </a:spcBef>
               <a:buChar char="•"/>
             </a:pPr>
             <a:r>
-              <a:rPr sz="1600">
-                <a:latin typeface="Times New Roman"/>
-                <a:cs typeface="Times New Roman"/>
-              </a:rPr>
-              <a:t>Same campaign split and real test set for every model</a:t>
+              <a:rPr sz="1500">
+                <a:latin typeface="Times New Roman"/>
+                <a:cs typeface="Times New Roman"/>
+              </a:rPr>
+              <a:t>Deployed system: 34 scams missed, 21 genuine flagged; 15 of the 21 are reported-but-genuine bank messages</a:t>
+            </a:r>
+          </a:p>
+          <a:p>
+            <a:pPr marL="228600" indent="-228600">
+              <a:spcBef>
+                <a:spcPts val="400"/>
+              </a:spcBef>
+              <a:buChar char="•"/>
+            </a:pPr>
+            <a:r>
+              <a:rPr sz="1500">
+                <a:latin typeface="Times New Roman"/>
+                <a:cs typeface="Times New Roman"/>
+              </a:rPr>
+              <a:t>Threshold 0.9: false alarms 0.8% at 92.5% recall</a:t>
+            </a:r>
+          </a:p>
+          <a:p>
+            <a:pPr marL="228600" indent="-228600">
+              <a:spcBef>
+                <a:spcPts val="400"/>
+              </a:spcBef>
+              <a:buChar char="•"/>
+            </a:pPr>
+            <a:r>
+              <a:rPr sz="1500">
+                <a:latin typeface="Times New Roman"/>
+                <a:cs typeface="Times New Roman"/>
+              </a:rPr>
+              <a:t>Model 1.6 MB; 3.8 ms per message</a:t>
             </a:r>
           </a:p>
         </p:txBody>
       </p:sp>
       <p:pic>
         <p:nvPicPr>
-          <p:cNvPr id="10" name="Picture 9" descr="roc_pr.png"/>
+          <p:cNvPr id="10" name="Picture 9" descr="confusion.png"/>
           <p:cNvPicPr>
             <a:picLocks noChangeAspect="1"/>
           </p:cNvPicPr>
@@ -9803,8 +9888,8 @@
         </p:blipFill>
         <p:spPr>
           <a:xfrm>
-            <a:off x="6050000" y="1750000"/>
-            <a:ext cx="5300000" cy="1948529"/>
+            <a:off x="6150000" y="1750000"/>
+            <a:ext cx="5200000" cy="2600000"/>
           </a:xfrm>
           <a:prstGeom prst="rect">
             <a:avLst/>
@@ -9819,8 +9904,8 @@
         </p:nvSpPr>
         <p:spPr>
           <a:xfrm>
-            <a:off x="6050000" y="4100000"/>
-            <a:ext cx="5300000" cy="400000"/>
+            <a:off x="6150000" y="4350000"/>
+            <a:ext cx="5200000" cy="400000"/>
           </a:xfrm>
           <a:prstGeom prst="rect">
             <a:avLst/>
@@ -9844,7 +9929,7 @@
                 <a:latin typeface="Times New Roman"/>
                 <a:cs typeface="Times New Roman"/>
               </a:rPr>
-              <a:t>ROC and precision-recall curves on the real test set</a:t>
+              <a:t>Deployed system: confusion matrix and threshold trade-off</a:t>
             </a:r>
           </a:p>
         </p:txBody>
@@ -9890,7 +9975,7 @@
                 <a:latin typeface="Times New Roman"/>
                 <a:cs typeface="Times New Roman"/>
               </a:rPr>
-              <a:t>Results: Errors, Threshold and Speed</a:t>
+              <a:t>Results: Snapshots of the Output (1/3)</a:t>
             </a:r>
           </a:p>
         </p:txBody>
@@ -10035,7 +10120,7 @@
       </p:sp>
       <p:pic>
         <p:nvPicPr>
-          <p:cNvPr id="8" name="Picture 7" descr="confusion.png"/>
+          <p:cNvPr id="8" name="Picture 7" descr="01_landing.jpg"/>
           <p:cNvPicPr>
             <a:picLocks noChangeAspect="1"/>
           </p:cNvPicPr>
@@ -10049,12 +10134,17 @@
         </p:blipFill>
         <p:spPr>
           <a:xfrm>
-            <a:off x="838200" y="1700000"/>
-            <a:ext cx="5600000" cy="2800000"/>
+            <a:off x="2568000" y="1480000"/>
+            <a:ext cx="3328000" cy="2080000"/>
           </a:xfrm>
           <a:prstGeom prst="rect">
             <a:avLst/>
           </a:prstGeom>
+          <a:ln w="9525">
+            <a:solidFill>
+              <a:srgbClr val="9AA0A6"/>
+            </a:solidFill>
+          </a:ln>
         </p:spPr>
       </p:pic>
       <p:sp>
@@ -10065,8 +10155,8 @@
         </p:nvSpPr>
         <p:spPr>
           <a:xfrm>
-            <a:off x="6700000" y="1650000"/>
-            <a:ext cx="4650000" cy="4500000"/>
+            <a:off x="2568000" y="3580000"/>
+            <a:ext cx="3328000" cy="400000"/>
           </a:xfrm>
           <a:prstGeom prst="rect">
             <a:avLst/>
@@ -10079,93 +10169,219 @@
           </a:bodyPr>
           <a:lstStyle/>
           <a:p>
-            <a:pPr marL="228600" indent="-228600">
+            <a:pPr indent="0" marL="0" algn="ctr">
+              <a:buNone/>
               <a:spcBef>
-                <a:spcPts val="600"/>
+                <a:spcPts val="0"/>
               </a:spcBef>
-              <a:buChar char="•"/>
             </a:pPr>
             <a:r>
-              <a:rPr sz="1600">
-                <a:latin typeface="Times New Roman"/>
-                <a:cs typeface="Times New Roman"/>
-              </a:rPr>
-              <a:t>34 scams missed, 21 genuine messages flagged at threshold 0.5</a:t>
-            </a:r>
-          </a:p>
-          <a:p>
-            <a:pPr marL="228600" indent="-228600">
+              <a:rPr sz="1300" i="1">
+                <a:latin typeface="Times New Roman"/>
+                <a:cs typeface="Times New Roman"/>
+              </a:rPr>
+              <a:t>Home page with the quick check</a:t>
+            </a:r>
+          </a:p>
+        </p:txBody>
+      </p:sp>
+      <p:pic>
+        <p:nvPicPr>
+          <p:cNvPr id="10" name="Picture 9" descr="02_quick_scam.jpg"/>
+          <p:cNvPicPr>
+            <a:picLocks noChangeAspect="1"/>
+          </p:cNvPicPr>
+          <p:nvPr/>
+        </p:nvPicPr>
+        <p:blipFill>
+          <a:blip r:embed="rId4"/>
+          <a:stretch>
+            <a:fillRect/>
+          </a:stretch>
+        </p:blipFill>
+        <p:spPr>
+          <a:xfrm>
+            <a:off x="6296000" y="1480000"/>
+            <a:ext cx="3328000" cy="2080000"/>
+          </a:xfrm>
+          <a:prstGeom prst="rect">
+            <a:avLst/>
+          </a:prstGeom>
+          <a:ln w="9525">
+            <a:solidFill>
+              <a:srgbClr val="9AA0A6"/>
+            </a:solidFill>
+          </a:ln>
+        </p:spPr>
+      </p:pic>
+      <p:sp>
+        <p:nvSpPr>
+          <p:cNvPr id="11" name="TextBox 10"/>
+          <p:cNvSpPr txBox="1"/>
+          <p:nvPr/>
+        </p:nvSpPr>
+        <p:spPr>
+          <a:xfrm>
+            <a:off x="6296000" y="3580000"/>
+            <a:ext cx="3328000" cy="400000"/>
+          </a:xfrm>
+          <a:prstGeom prst="rect">
+            <a:avLst/>
+          </a:prstGeom>
+          <a:noFill/>
+        </p:spPr>
+        <p:txBody>
+          <a:bodyPr wrap="square">
+            <a:spAutoFit/>
+          </a:bodyPr>
+          <a:lstStyle/>
+          <a:p>
+            <a:pPr indent="0" marL="0" algn="ctr">
+              <a:buNone/>
               <a:spcBef>
-                <a:spcPts val="600"/>
+                <a:spcPts val="0"/>
               </a:spcBef>
-              <a:buChar char="•"/>
             </a:pPr>
             <a:r>
-              <a:rPr sz="1600">
-                <a:latin typeface="Times New Roman"/>
-                <a:cs typeface="Times New Roman"/>
-              </a:rPr>
-              <a:t>15 of the 21 are reported-but-genuine bank messages asking the user to click a link</a:t>
-            </a:r>
-          </a:p>
-          <a:p>
-            <a:pPr marL="228600" indent="-228600">
+              <a:rPr sz="1300" i="1">
+                <a:latin typeface="Times New Roman"/>
+                <a:cs typeface="Times New Roman"/>
+              </a:rPr>
+              <a:t>Fake KYC SMS flagged as scam</a:t>
+            </a:r>
+          </a:p>
+        </p:txBody>
+      </p:sp>
+      <p:pic>
+        <p:nvPicPr>
+          <p:cNvPr id="12" name="Picture 11" descr="03_quick_genuine.jpg"/>
+          <p:cNvPicPr>
+            <a:picLocks noChangeAspect="1"/>
+          </p:cNvPicPr>
+          <p:nvPr/>
+        </p:nvPicPr>
+        <p:blipFill>
+          <a:blip r:embed="rId5"/>
+          <a:stretch>
+            <a:fillRect/>
+          </a:stretch>
+        </p:blipFill>
+        <p:spPr>
+          <a:xfrm>
+            <a:off x="2568000" y="3930000"/>
+            <a:ext cx="3328000" cy="2080000"/>
+          </a:xfrm>
+          <a:prstGeom prst="rect">
+            <a:avLst/>
+          </a:prstGeom>
+          <a:ln w="9525">
+            <a:solidFill>
+              <a:srgbClr val="9AA0A6"/>
+            </a:solidFill>
+          </a:ln>
+        </p:spPr>
+      </p:pic>
+      <p:sp>
+        <p:nvSpPr>
+          <p:cNvPr id="13" name="TextBox 12"/>
+          <p:cNvSpPr txBox="1"/>
+          <p:nvPr/>
+        </p:nvSpPr>
+        <p:spPr>
+          <a:xfrm>
+            <a:off x="2568000" y="6030000"/>
+            <a:ext cx="3328000" cy="400000"/>
+          </a:xfrm>
+          <a:prstGeom prst="rect">
+            <a:avLst/>
+          </a:prstGeom>
+          <a:noFill/>
+        </p:spPr>
+        <p:txBody>
+          <a:bodyPr wrap="square">
+            <a:spAutoFit/>
+          </a:bodyPr>
+          <a:lstStyle/>
+          <a:p>
+            <a:pPr indent="0" marL="0" algn="ctr">
+              <a:buNone/>
               <a:spcBef>
-                <a:spcPts val="600"/>
+                <a:spcPts val="0"/>
               </a:spcBef>
-              <a:buChar char="•"/>
             </a:pPr>
             <a:r>
-              <a:rPr sz="1600">
-                <a:latin typeface="Times New Roman"/>
-                <a:cs typeface="Times New Roman"/>
-              </a:rPr>
-              <a:t>Threshold 0.9: false alarms 0.8% at 92.5% recall</a:t>
-            </a:r>
-          </a:p>
-          <a:p>
-            <a:pPr marL="228600" indent="-228600">
+              <a:rPr sz="1300" i="1">
+                <a:latin typeface="Times New Roman"/>
+                <a:cs typeface="Times New Roman"/>
+              </a:rPr>
+              <a:t>Operator 1909 notice: looks genuine</a:t>
+            </a:r>
+          </a:p>
+        </p:txBody>
+      </p:sp>
+      <p:pic>
+        <p:nvPicPr>
+          <p:cNvPr id="14" name="Picture 13" descr="05_analyze_result.jpg"/>
+          <p:cNvPicPr>
+            <a:picLocks noChangeAspect="1"/>
+          </p:cNvPicPr>
+          <p:nvPr/>
+        </p:nvPicPr>
+        <p:blipFill>
+          <a:blip r:embed="rId6"/>
+          <a:stretch>
+            <a:fillRect/>
+          </a:stretch>
+        </p:blipFill>
+        <p:spPr>
+          <a:xfrm>
+            <a:off x="6296000" y="3930000"/>
+            <a:ext cx="3328000" cy="2080000"/>
+          </a:xfrm>
+          <a:prstGeom prst="rect">
+            <a:avLst/>
+          </a:prstGeom>
+          <a:ln w="9525">
+            <a:solidFill>
+              <a:srgbClr val="9AA0A6"/>
+            </a:solidFill>
+          </a:ln>
+        </p:spPr>
+      </p:pic>
+      <p:sp>
+        <p:nvSpPr>
+          <p:cNvPr id="15" name="TextBox 14"/>
+          <p:cNvSpPr txBox="1"/>
+          <p:nvPr/>
+        </p:nvSpPr>
+        <p:spPr>
+          <a:xfrm>
+            <a:off x="6296000" y="6030000"/>
+            <a:ext cx="3328000" cy="400000"/>
+          </a:xfrm>
+          <a:prstGeom prst="rect">
+            <a:avLst/>
+          </a:prstGeom>
+          <a:noFill/>
+        </p:spPr>
+        <p:txBody>
+          <a:bodyPr wrap="square">
+            <a:spAutoFit/>
+          </a:bodyPr>
+          <a:lstStyle/>
+          <a:p>
+            <a:pPr indent="0" marL="0" algn="ctr">
+              <a:buNone/>
               <a:spcBef>
-                <a:spcPts val="600"/>
+                <a:spcPts val="0"/>
               </a:spcBef>
-              <a:buChar char="•"/>
             </a:pPr>
             <a:r>
-              <a:rPr sz="1600">
-                <a:latin typeface="Times New Roman"/>
-                <a:cs typeface="Times New Roman"/>
-              </a:rPr>
-              <a:t>Recall: banking 97.7% (895/916), government 92.3% (24/26)</a:t>
-            </a:r>
-          </a:p>
-          <a:p>
-            <a:pPr marL="228600" indent="-228600">
-              <a:spcBef>
-                <a:spcPts val="600"/>
-              </a:spcBef>
-              <a:buChar char="•"/>
-            </a:pPr>
-            <a:r>
-              <a:rPr sz="1600">
-                <a:latin typeface="Times New Roman"/>
-                <a:cs typeface="Times New Roman"/>
-              </a:rPr>
-              <a:t>Obfuscated keywords (837 scams): recall 99.4% → 99.3%</a:t>
-            </a:r>
-          </a:p>
-          <a:p>
-            <a:pPr marL="228600" indent="-228600">
-              <a:spcBef>
-                <a:spcPts val="600"/>
-              </a:spcBef>
-              <a:buChar char="•"/>
-            </a:pPr>
-            <a:r>
-              <a:rPr sz="1600">
-                <a:latin typeface="Times New Roman"/>
-                <a:cs typeface="Times New Roman"/>
-              </a:rPr>
-              <a:t>Model 1.6 MB; training 2.7 s; 3.8 ms per message</a:t>
+              <a:rPr sz="1300" i="1">
+                <a:latin typeface="Times New Roman"/>
+                <a:cs typeface="Times New Roman"/>
+              </a:rPr>
+              <a:t>Full analysis of a scam message</a:t>
             </a:r>
           </a:p>
         </p:txBody>
@@ -10211,7 +10427,7 @@
                 <a:latin typeface="Times New Roman"/>
                 <a:cs typeface="Times New Roman"/>
               </a:rPr>
-              <a:t>Results: Snapshots of the Output (1/6)</a:t>
+              <a:t>Results: Snapshots of the Output (2/3)</a:t>
             </a:r>
           </a:p>
         </p:txBody>
@@ -10356,7 +10572,7 @@
       </p:sp>
       <p:pic>
         <p:nvPicPr>
-          <p:cNvPr id="8" name="Picture 7" descr="01_landing.jpg"/>
+          <p:cNvPr id="8" name="Picture 7" descr="06_analyze_xray.jpg"/>
           <p:cNvPicPr>
             <a:picLocks noChangeAspect="1"/>
           </p:cNvPicPr>
@@ -10370,8 +10586,8 @@
         </p:blipFill>
         <p:spPr>
           <a:xfrm>
-            <a:off x="838200" y="1700000"/>
-            <a:ext cx="5182800" cy="3239250"/>
+            <a:off x="2568000" y="1480000"/>
+            <a:ext cx="3328000" cy="2080000"/>
           </a:xfrm>
           <a:prstGeom prst="rect">
             <a:avLst/>
@@ -10383,9 +10599,47 @@
           </a:ln>
         </p:spPr>
       </p:pic>
+      <p:sp>
+        <p:nvSpPr>
+          <p:cNvPr id="9" name="TextBox 8"/>
+          <p:cNvSpPr txBox="1"/>
+          <p:nvPr/>
+        </p:nvSpPr>
+        <p:spPr>
+          <a:xfrm>
+            <a:off x="2568000" y="3580000"/>
+            <a:ext cx="3328000" cy="400000"/>
+          </a:xfrm>
+          <a:prstGeom prst="rect">
+            <a:avLst/>
+          </a:prstGeom>
+          <a:noFill/>
+        </p:spPr>
+        <p:txBody>
+          <a:bodyPr wrap="square">
+            <a:spAutoFit/>
+          </a:bodyPr>
+          <a:lstStyle/>
+          <a:p>
+            <a:pPr indent="0" marL="0" algn="ctr">
+              <a:buNone/>
+              <a:spcBef>
+                <a:spcPts val="0"/>
+              </a:spcBef>
+            </a:pPr>
+            <a:r>
+              <a:rPr sz="1300" i="1">
+                <a:latin typeface="Times New Roman"/>
+                <a:cs typeface="Times New Roman"/>
+              </a:rPr>
+              <a:t>Scam X-Ray: risky phrases by stage</a:t>
+            </a:r>
+          </a:p>
+        </p:txBody>
+      </p:sp>
       <p:pic>
         <p:nvPicPr>
-          <p:cNvPr id="9" name="Picture 8" descr="02_quick_scam.jpg"/>
+          <p:cNvPr id="10" name="Picture 9" descr="07_analyze_trustlens.jpg"/>
           <p:cNvPicPr>
             <a:picLocks noChangeAspect="1"/>
           </p:cNvPicPr>
@@ -10399,8 +10653,8 @@
         </p:blipFill>
         <p:spPr>
           <a:xfrm>
-            <a:off x="6171000" y="1700000"/>
-            <a:ext cx="5182800" cy="3239250"/>
+            <a:off x="6296000" y="1480000"/>
+            <a:ext cx="3328000" cy="2080000"/>
           </a:xfrm>
           <a:prstGeom prst="rect">
             <a:avLst/>
@@ -10414,14 +10668,14 @@
       </p:pic>
       <p:sp>
         <p:nvSpPr>
-          <p:cNvPr id="10" name="TextBox 9"/>
+          <p:cNvPr id="11" name="TextBox 10"/>
           <p:cNvSpPr txBox="1"/>
           <p:nvPr/>
         </p:nvSpPr>
         <p:spPr>
           <a:xfrm>
-            <a:off x="838200" y="5000000"/>
-            <a:ext cx="5182800" cy="400000"/>
+            <a:off x="6296000" y="3580000"/>
+            <a:ext cx="3328000" cy="400000"/>
           </a:xfrm>
           <a:prstGeom prst="rect">
             <a:avLst/>
@@ -10441,25 +10695,54 @@
               </a:spcBef>
             </a:pPr>
             <a:r>
-              <a:rPr sz="1400" i="1">
-                <a:latin typeface="Times New Roman"/>
-                <a:cs typeface="Times New Roman"/>
-              </a:rPr>
-              <a:t>Home page with the quick check</a:t>
-            </a:r>
-          </a:p>
-        </p:txBody>
-      </p:sp>
-      <p:sp>
-        <p:nvSpPr>
-          <p:cNvPr id="11" name="TextBox 10"/>
+              <a:rPr sz="1300" i="1">
+                <a:latin typeface="Times New Roman"/>
+                <a:cs typeface="Times New Roman"/>
+              </a:rPr>
+              <a:t>TrustLens: scam journey, next steps</a:t>
+            </a:r>
+          </a:p>
+        </p:txBody>
+      </p:sp>
+      <p:pic>
+        <p:nvPicPr>
+          <p:cNvPr id="12" name="Picture 11" descr="08_dashboard.jpg"/>
+          <p:cNvPicPr>
+            <a:picLocks noChangeAspect="1"/>
+          </p:cNvPicPr>
+          <p:nvPr/>
+        </p:nvPicPr>
+        <p:blipFill>
+          <a:blip r:embed="rId5"/>
+          <a:stretch>
+            <a:fillRect/>
+          </a:stretch>
+        </p:blipFill>
+        <p:spPr>
+          <a:xfrm>
+            <a:off x="2568000" y="3930000"/>
+            <a:ext cx="3328000" cy="2080000"/>
+          </a:xfrm>
+          <a:prstGeom prst="rect">
+            <a:avLst/>
+          </a:prstGeom>
+          <a:ln w="9525">
+            <a:solidFill>
+              <a:srgbClr val="9AA0A6"/>
+            </a:solidFill>
+          </a:ln>
+        </p:spPr>
+      </p:pic>
+      <p:sp>
+        <p:nvSpPr>
+          <p:cNvPr id="13" name="TextBox 12"/>
           <p:cNvSpPr txBox="1"/>
           <p:nvPr/>
         </p:nvSpPr>
         <p:spPr>
           <a:xfrm>
-            <a:off x="6171000" y="5000000"/>
-            <a:ext cx="5182800" cy="400000"/>
+            <a:off x="2568000" y="6030000"/>
+            <a:ext cx="3328000" cy="400000"/>
           </a:xfrm>
           <a:prstGeom prst="rect">
             <a:avLst/>
@@ -10479,11 +10762,78 @@
               </a:spcBef>
             </a:pPr>
             <a:r>
-              <a:rPr sz="1400" i="1">
-                <a:latin typeface="Times New Roman"/>
-                <a:cs typeface="Times New Roman"/>
-              </a:rPr>
-              <a:t>Fake KYC SMS: likely scam, with matched tactics</a:t>
+              <a:rPr sz="1300" i="1">
+                <a:latin typeface="Times New Roman"/>
+                <a:cs typeface="Times New Roman"/>
+              </a:rPr>
+              <a:t>Dashboard: priority findings</a:t>
+            </a:r>
+          </a:p>
+        </p:txBody>
+      </p:sp>
+      <p:pic>
+        <p:nvPicPr>
+          <p:cNvPr id="14" name="Picture 13" descr="09_history.jpg"/>
+          <p:cNvPicPr>
+            <a:picLocks noChangeAspect="1"/>
+          </p:cNvPicPr>
+          <p:nvPr/>
+        </p:nvPicPr>
+        <p:blipFill>
+          <a:blip r:embed="rId6"/>
+          <a:stretch>
+            <a:fillRect/>
+          </a:stretch>
+        </p:blipFill>
+        <p:spPr>
+          <a:xfrm>
+            <a:off x="6296000" y="3930000"/>
+            <a:ext cx="3328000" cy="2080000"/>
+          </a:xfrm>
+          <a:prstGeom prst="rect">
+            <a:avLst/>
+          </a:prstGeom>
+          <a:ln w="9525">
+            <a:solidFill>
+              <a:srgbClr val="9AA0A6"/>
+            </a:solidFill>
+          </a:ln>
+        </p:spPr>
+      </p:pic>
+      <p:sp>
+        <p:nvSpPr>
+          <p:cNvPr id="15" name="TextBox 14"/>
+          <p:cNvSpPr txBox="1"/>
+          <p:nvPr/>
+        </p:nvSpPr>
+        <p:spPr>
+          <a:xfrm>
+            <a:off x="6296000" y="6030000"/>
+            <a:ext cx="3328000" cy="400000"/>
+          </a:xfrm>
+          <a:prstGeom prst="rect">
+            <a:avLst/>
+          </a:prstGeom>
+          <a:noFill/>
+        </p:spPr>
+        <p:txBody>
+          <a:bodyPr wrap="square">
+            <a:spAutoFit/>
+          </a:bodyPr>
+          <a:lstStyle/>
+          <a:p>
+            <a:pPr indent="0" marL="0" algn="ctr">
+              <a:buNone/>
+              <a:spcBef>
+                <a:spcPts val="0"/>
+              </a:spcBef>
+            </a:pPr>
+            <a:r>
+              <a:rPr sz="1300" i="1">
+                <a:latin typeface="Times New Roman"/>
+                <a:cs typeface="Times New Roman"/>
+              </a:rPr>
+              <a:t>Scan history with filters and export</a:t>
             </a:r>
           </a:p>
         </p:txBody>
@@ -10529,7 +10879,7 @@
                 <a:latin typeface="Times New Roman"/>
                 <a:cs typeface="Times New Roman"/>
               </a:rPr>
-              <a:t>Results: Snapshots of the Output (2/6)</a:t>
+              <a:t>Results: Snapshots of the Output (3/3)</a:t>
             </a:r>
           </a:p>
         </p:txBody>
@@ -10674,960 +11024,6 @@
       </p:sp>
       <p:pic>
         <p:nvPicPr>
-          <p:cNvPr id="8" name="Picture 7" descr="03_quick_genuine.jpg"/>
-          <p:cNvPicPr>
-            <a:picLocks noChangeAspect="1"/>
-          </p:cNvPicPr>
-          <p:nvPr/>
-        </p:nvPicPr>
-        <p:blipFill>
-          <a:blip r:embed="rId3"/>
-          <a:stretch>
-            <a:fillRect/>
-          </a:stretch>
-        </p:blipFill>
-        <p:spPr>
-          <a:xfrm>
-            <a:off x="838200" y="1700000"/>
-            <a:ext cx="5182800" cy="3239250"/>
-          </a:xfrm>
-          <a:prstGeom prst="rect">
-            <a:avLst/>
-          </a:prstGeom>
-          <a:ln w="9525">
-            <a:solidFill>
-              <a:srgbClr val="9AA0A6"/>
-            </a:solidFill>
-          </a:ln>
-        </p:spPr>
-      </p:pic>
-      <p:pic>
-        <p:nvPicPr>
-          <p:cNvPr id="9" name="Picture 8" descr="05_analyze_result.jpg"/>
-          <p:cNvPicPr>
-            <a:picLocks noChangeAspect="1"/>
-          </p:cNvPicPr>
-          <p:nvPr/>
-        </p:nvPicPr>
-        <p:blipFill>
-          <a:blip r:embed="rId4"/>
-          <a:stretch>
-            <a:fillRect/>
-          </a:stretch>
-        </p:blipFill>
-        <p:spPr>
-          <a:xfrm>
-            <a:off x="6171000" y="1700000"/>
-            <a:ext cx="5182800" cy="3239250"/>
-          </a:xfrm>
-          <a:prstGeom prst="rect">
-            <a:avLst/>
-          </a:prstGeom>
-          <a:ln w="9525">
-            <a:solidFill>
-              <a:srgbClr val="9AA0A6"/>
-            </a:solidFill>
-          </a:ln>
-        </p:spPr>
-      </p:pic>
-      <p:sp>
-        <p:nvSpPr>
-          <p:cNvPr id="10" name="TextBox 9"/>
-          <p:cNvSpPr txBox="1"/>
-          <p:nvPr/>
-        </p:nvSpPr>
-        <p:spPr>
-          <a:xfrm>
-            <a:off x="838200" y="5000000"/>
-            <a:ext cx="5182800" cy="400000"/>
-          </a:xfrm>
-          <a:prstGeom prst="rect">
-            <a:avLst/>
-          </a:prstGeom>
-          <a:noFill/>
-        </p:spPr>
-        <p:txBody>
-          <a:bodyPr wrap="square">
-            <a:spAutoFit/>
-          </a:bodyPr>
-          <a:lstStyle/>
-          <a:p>
-            <a:pPr indent="0" marL="0" algn="ctr">
-              <a:buNone/>
-              <a:spcBef>
-                <a:spcPts val="0"/>
-              </a:spcBef>
-            </a:pPr>
-            <a:r>
-              <a:rPr sz="1400" i="1">
-                <a:latin typeface="Times New Roman"/>
-                <a:cs typeface="Times New Roman"/>
-              </a:rPr>
-              <a:t>Operator 1909 notice: looks genuine, with the reason</a:t>
-            </a:r>
-          </a:p>
-        </p:txBody>
-      </p:sp>
-      <p:sp>
-        <p:nvSpPr>
-          <p:cNvPr id="11" name="TextBox 10"/>
-          <p:cNvSpPr txBox="1"/>
-          <p:nvPr/>
-        </p:nvSpPr>
-        <p:spPr>
-          <a:xfrm>
-            <a:off x="6171000" y="5000000"/>
-            <a:ext cx="5182800" cy="400000"/>
-          </a:xfrm>
-          <a:prstGeom prst="rect">
-            <a:avLst/>
-          </a:prstGeom>
-          <a:noFill/>
-        </p:spPr>
-        <p:txBody>
-          <a:bodyPr wrap="square">
-            <a:spAutoFit/>
-          </a:bodyPr>
-          <a:lstStyle/>
-          <a:p>
-            <a:pPr indent="0" marL="0" algn="ctr">
-              <a:buNone/>
-              <a:spcBef>
-                <a:spcPts val="0"/>
-              </a:spcBef>
-            </a:pPr>
-            <a:r>
-              <a:rPr sz="1400" i="1">
-                <a:latin typeface="Times New Roman"/>
-                <a:cs typeface="Times New Roman"/>
-              </a:rPr>
-              <a:t>Full analysis of a scam message</a:t>
-            </a:r>
-          </a:p>
-        </p:txBody>
-      </p:sp>
-    </p:spTree>
-  </p:cSld>
-  <p:clrMapOvr>
-    <a:masterClrMapping/>
-  </p:clrMapOvr>
-</p:sld>
-</file>
-
-<file path=ppt/slides/slide24.xml><?xml version="1.0" encoding="utf-8"?>
-<p:sld xmlns:a="http://schemas.openxmlformats.org/drawingml/2006/main" xmlns:p="http://schemas.openxmlformats.org/presentationml/2006/main" xmlns:r="http://schemas.openxmlformats.org/officeDocument/2006/relationships">
-  <p:cSld>
-    <p:spTree>
-      <p:nvGrpSpPr>
-        <p:cNvPr id="1" name=""/>
-        <p:cNvGrpSpPr/>
-        <p:nvPr/>
-      </p:nvGrpSpPr>
-      <p:grpSpPr/>
-      <p:sp>
-        <p:nvSpPr>
-          <p:cNvPr id="2" name="Title 1"/>
-          <p:cNvSpPr>
-            <a:spLocks noGrp="1"/>
-          </p:cNvSpPr>
-          <p:nvPr>
-            <p:ph type="title"/>
-          </p:nvPr>
-        </p:nvSpPr>
-        <p:spPr/>
-        <p:txBody>
-          <a:bodyPr/>
-          <a:lstStyle/>
-          <a:p>
-            <a:r>
-              <a:rPr b="1" sz="3200">
-                <a:solidFill>
-                  <a:srgbClr val="1F2A44"/>
-                </a:solidFill>
-                <a:latin typeface="Times New Roman"/>
-                <a:cs typeface="Times New Roman"/>
-              </a:rPr>
-              <a:t>Results: Snapshots of the Output (3/6)</a:t>
-            </a:r>
-          </a:p>
-        </p:txBody>
-      </p:sp>
-      <p:sp>
-        <p:nvSpPr>
-          <p:cNvPr id="4" name="Footer Placeholder 3"/>
-          <p:cNvSpPr>
-            <a:spLocks noGrp="1"/>
-          </p:cNvSpPr>
-          <p:nvPr>
-            <p:ph type="ftr" sz="quarter" idx="11"/>
-          </p:nvPr>
-        </p:nvSpPr>
-        <p:spPr>
-          <a:xfrm>
-            <a:off x="2700000" y="6356350"/>
-            <a:ext cx="6800000" cy="365125"/>
-          </a:xfrm>
-        </p:spPr>
-        <p:txBody>
-          <a:bodyPr/>
-          <a:lstStyle/>
-          <a:p>
-            <a:r>
-              <a:rPr sz="1100">
-                <a:latin typeface="Times New Roman"/>
-                <a:cs typeface="Times New Roman"/>
-              </a:rPr>
-              <a:t>ScamGuard: AI-Based Online Scam and Fraud Detection System   |   Department of CSE, BMSCE</a:t>
-            </a:r>
-          </a:p>
-        </p:txBody>
-      </p:sp>
-      <p:sp>
-        <p:nvSpPr>
-          <p:cNvPr id="5" name="Slide Number Placeholder 4"/>
-          <p:cNvSpPr>
-            <a:spLocks noGrp="1"/>
-          </p:cNvSpPr>
-          <p:nvPr>
-            <p:ph type="sldNum" sz="quarter" idx="12"/>
-          </p:nvPr>
-        </p:nvSpPr>
-        <p:spPr/>
-        <p:txBody>
-          <a:bodyPr/>
-          <a:lstStyle/>
-          <a:p>
-            <a:fld id="{840E0BF8-4B7D-46FA-B28A-DDF089F57DAF}" type="slidenum">
-              <a:rPr lang="en-IN" smtClean="0">
-                <a:latin typeface="Times New Roman"/>
-                <a:cs typeface="Times New Roman"/>
-              </a:rPr>
-              <a:t>6</a:t>
-            </a:fld>
-            <a:endParaRPr lang="en-IN">
-              <a:latin typeface="Times New Roman"/>
-              <a:cs typeface="Times New Roman"/>
-            </a:endParaRPr>
-          </a:p>
-        </p:txBody>
-      </p:sp>
-      <p:pic>
-        <p:nvPicPr>
-          <p:cNvPr id="6" name="Picture 1"/>
-          <p:cNvPicPr>
-            <a:picLocks noChangeAspect="1"/>
-          </p:cNvPicPr>
-          <p:nvPr/>
-        </p:nvPicPr>
-        <p:blipFill>
-          <a:blip r:embed="rId2">
-            <a:extLst>
-              <a:ext uri="{28A0092B-C50C-407E-A947-70E740481C1C}">
-                <a14:useLocalDpi xmlns:a14="http://schemas.microsoft.com/office/drawing/2010/main" val="0"/>
-              </a:ext>
-            </a:extLst>
-          </a:blip>
-          <a:srcRect/>
-          <a:stretch>
-            <a:fillRect/>
-          </a:stretch>
-        </p:blipFill>
-        <p:spPr bwMode="auto">
-          <a:xfrm>
-            <a:off x="11028362" y="19050"/>
-            <a:ext cx="1163638" cy="1144588"/>
-          </a:xfrm>
-          <a:prstGeom prst="rect">
-            <a:avLst/>
-          </a:prstGeom>
-          <a:noFill/>
-          <a:ln>
-            <a:noFill/>
-          </a:ln>
-          <a:extLst>
-            <a:ext uri="{909E8E84-426E-40DD-AFC4-6F175D3DCCD1}">
-              <a14:hiddenFill xmlns:a14="http://schemas.microsoft.com/office/drawing/2010/main">
-                <a:solidFill>
-                  <a:srgbClr val="FFFFFF"/>
-                </a:solidFill>
-              </a14:hiddenFill>
-            </a:ext>
-            <a:ext uri="{91240B29-F687-4F45-9708-019B960494DF}">
-              <a14:hiddenLine xmlns:a14="http://schemas.microsoft.com/office/drawing/2010/main" w="9525">
-                <a:solidFill>
-                  <a:srgbClr val="000000"/>
-                </a:solidFill>
-                <a:miter lim="800000"/>
-                <a:headEnd/>
-                <a:tailEnd/>
-              </a14:hiddenLine>
-            </a:ext>
-          </a:extLst>
-        </p:spPr>
-      </p:pic>
-      <p:sp>
-        <p:nvSpPr>
-          <p:cNvPr id="7" name="Date Placeholder 6"/>
-          <p:cNvSpPr>
-            <a:spLocks noGrp="1"/>
-          </p:cNvSpPr>
-          <p:nvPr>
-            <p:ph type="dt" sz="half" idx="10"/>
-          </p:nvPr>
-        </p:nvSpPr>
-        <p:spPr/>
-        <p:txBody>
-          <a:bodyPr/>
-          <a:lstStyle/>
-          <a:p>
-            <a:r>
-              <a:rPr>
-                <a:latin typeface="Times New Roman"/>
-                <a:cs typeface="Times New Roman"/>
-              </a:rPr>
-              <a:t>20-10-2026</a:t>
-            </a:r>
-          </a:p>
-        </p:txBody>
-      </p:sp>
-      <p:pic>
-        <p:nvPicPr>
-          <p:cNvPr id="8" name="Picture 7" descr="06_analyze_xray.jpg"/>
-          <p:cNvPicPr>
-            <a:picLocks noChangeAspect="1"/>
-          </p:cNvPicPr>
-          <p:nvPr/>
-        </p:nvPicPr>
-        <p:blipFill>
-          <a:blip r:embed="rId3"/>
-          <a:stretch>
-            <a:fillRect/>
-          </a:stretch>
-        </p:blipFill>
-        <p:spPr>
-          <a:xfrm>
-            <a:off x="838200" y="1700000"/>
-            <a:ext cx="5182800" cy="3239250"/>
-          </a:xfrm>
-          <a:prstGeom prst="rect">
-            <a:avLst/>
-          </a:prstGeom>
-          <a:ln w="9525">
-            <a:solidFill>
-              <a:srgbClr val="9AA0A6"/>
-            </a:solidFill>
-          </a:ln>
-        </p:spPr>
-      </p:pic>
-      <p:pic>
-        <p:nvPicPr>
-          <p:cNvPr id="9" name="Picture 8" descr="07_analyze_trustlens.jpg"/>
-          <p:cNvPicPr>
-            <a:picLocks noChangeAspect="1"/>
-          </p:cNvPicPr>
-          <p:nvPr/>
-        </p:nvPicPr>
-        <p:blipFill>
-          <a:blip r:embed="rId4"/>
-          <a:stretch>
-            <a:fillRect/>
-          </a:stretch>
-        </p:blipFill>
-        <p:spPr>
-          <a:xfrm>
-            <a:off x="6171000" y="1700000"/>
-            <a:ext cx="5182800" cy="3239250"/>
-          </a:xfrm>
-          <a:prstGeom prst="rect">
-            <a:avLst/>
-          </a:prstGeom>
-          <a:ln w="9525">
-            <a:solidFill>
-              <a:srgbClr val="9AA0A6"/>
-            </a:solidFill>
-          </a:ln>
-        </p:spPr>
-      </p:pic>
-      <p:sp>
-        <p:nvSpPr>
-          <p:cNvPr id="10" name="TextBox 9"/>
-          <p:cNvSpPr txBox="1"/>
-          <p:nvPr/>
-        </p:nvSpPr>
-        <p:spPr>
-          <a:xfrm>
-            <a:off x="838200" y="5000000"/>
-            <a:ext cx="5182800" cy="400000"/>
-          </a:xfrm>
-          <a:prstGeom prst="rect">
-            <a:avLst/>
-          </a:prstGeom>
-          <a:noFill/>
-        </p:spPr>
-        <p:txBody>
-          <a:bodyPr wrap="square">
-            <a:spAutoFit/>
-          </a:bodyPr>
-          <a:lstStyle/>
-          <a:p>
-            <a:pPr indent="0" marL="0" algn="ctr">
-              <a:buNone/>
-              <a:spcBef>
-                <a:spcPts val="0"/>
-              </a:spcBef>
-            </a:pPr>
-            <a:r>
-              <a:rPr sz="1400" i="1">
-                <a:latin typeface="Times New Roman"/>
-                <a:cs typeface="Times New Roman"/>
-              </a:rPr>
-              <a:t>Scam X-Ray: risky phrases by scam stage</a:t>
-            </a:r>
-          </a:p>
-        </p:txBody>
-      </p:sp>
-      <p:sp>
-        <p:nvSpPr>
-          <p:cNvPr id="11" name="TextBox 10"/>
-          <p:cNvSpPr txBox="1"/>
-          <p:nvPr/>
-        </p:nvSpPr>
-        <p:spPr>
-          <a:xfrm>
-            <a:off x="6171000" y="5000000"/>
-            <a:ext cx="5182800" cy="400000"/>
-          </a:xfrm>
-          <a:prstGeom prst="rect">
-            <a:avLst/>
-          </a:prstGeom>
-          <a:noFill/>
-        </p:spPr>
-        <p:txBody>
-          <a:bodyPr wrap="square">
-            <a:spAutoFit/>
-          </a:bodyPr>
-          <a:lstStyle/>
-          <a:p>
-            <a:pPr indent="0" marL="0" algn="ctr">
-              <a:buNone/>
-              <a:spcBef>
-                <a:spcPts val="0"/>
-              </a:spcBef>
-            </a:pPr>
-            <a:r>
-              <a:rPr sz="1400" i="1">
-                <a:latin typeface="Times New Roman"/>
-                <a:cs typeface="Times New Roman"/>
-              </a:rPr>
-              <a:t>TrustLens: scam journey and what to do</a:t>
-            </a:r>
-          </a:p>
-        </p:txBody>
-      </p:sp>
-    </p:spTree>
-  </p:cSld>
-  <p:clrMapOvr>
-    <a:masterClrMapping/>
-  </p:clrMapOvr>
-</p:sld>
-</file>
-
-<file path=ppt/slides/slide25.xml><?xml version="1.0" encoding="utf-8"?>
-<p:sld xmlns:a="http://schemas.openxmlformats.org/drawingml/2006/main" xmlns:p="http://schemas.openxmlformats.org/presentationml/2006/main" xmlns:r="http://schemas.openxmlformats.org/officeDocument/2006/relationships">
-  <p:cSld>
-    <p:spTree>
-      <p:nvGrpSpPr>
-        <p:cNvPr id="1" name=""/>
-        <p:cNvGrpSpPr/>
-        <p:nvPr/>
-      </p:nvGrpSpPr>
-      <p:grpSpPr/>
-      <p:sp>
-        <p:nvSpPr>
-          <p:cNvPr id="2" name="Title 1"/>
-          <p:cNvSpPr>
-            <a:spLocks noGrp="1"/>
-          </p:cNvSpPr>
-          <p:nvPr>
-            <p:ph type="title"/>
-          </p:nvPr>
-        </p:nvSpPr>
-        <p:spPr/>
-        <p:txBody>
-          <a:bodyPr/>
-          <a:lstStyle/>
-          <a:p>
-            <a:r>
-              <a:rPr b="1" sz="3200">
-                <a:solidFill>
-                  <a:srgbClr val="1F2A44"/>
-                </a:solidFill>
-                <a:latin typeface="Times New Roman"/>
-                <a:cs typeface="Times New Roman"/>
-              </a:rPr>
-              <a:t>Results: Snapshots of the Output (4/6)</a:t>
-            </a:r>
-          </a:p>
-        </p:txBody>
-      </p:sp>
-      <p:sp>
-        <p:nvSpPr>
-          <p:cNvPr id="4" name="Footer Placeholder 3"/>
-          <p:cNvSpPr>
-            <a:spLocks noGrp="1"/>
-          </p:cNvSpPr>
-          <p:nvPr>
-            <p:ph type="ftr" sz="quarter" idx="11"/>
-          </p:nvPr>
-        </p:nvSpPr>
-        <p:spPr>
-          <a:xfrm>
-            <a:off x="2700000" y="6356350"/>
-            <a:ext cx="6800000" cy="365125"/>
-          </a:xfrm>
-        </p:spPr>
-        <p:txBody>
-          <a:bodyPr/>
-          <a:lstStyle/>
-          <a:p>
-            <a:r>
-              <a:rPr sz="1100">
-                <a:latin typeface="Times New Roman"/>
-                <a:cs typeface="Times New Roman"/>
-              </a:rPr>
-              <a:t>ScamGuard: AI-Based Online Scam and Fraud Detection System   |   Department of CSE, BMSCE</a:t>
-            </a:r>
-          </a:p>
-        </p:txBody>
-      </p:sp>
-      <p:sp>
-        <p:nvSpPr>
-          <p:cNvPr id="5" name="Slide Number Placeholder 4"/>
-          <p:cNvSpPr>
-            <a:spLocks noGrp="1"/>
-          </p:cNvSpPr>
-          <p:nvPr>
-            <p:ph type="sldNum" sz="quarter" idx="12"/>
-          </p:nvPr>
-        </p:nvSpPr>
-        <p:spPr/>
-        <p:txBody>
-          <a:bodyPr/>
-          <a:lstStyle/>
-          <a:p>
-            <a:fld id="{840E0BF8-4B7D-46FA-B28A-DDF089F57DAF}" type="slidenum">
-              <a:rPr lang="en-IN" smtClean="0">
-                <a:latin typeface="Times New Roman"/>
-                <a:cs typeface="Times New Roman"/>
-              </a:rPr>
-              <a:t>6</a:t>
-            </a:fld>
-            <a:endParaRPr lang="en-IN">
-              <a:latin typeface="Times New Roman"/>
-              <a:cs typeface="Times New Roman"/>
-            </a:endParaRPr>
-          </a:p>
-        </p:txBody>
-      </p:sp>
-      <p:pic>
-        <p:nvPicPr>
-          <p:cNvPr id="6" name="Picture 1"/>
-          <p:cNvPicPr>
-            <a:picLocks noChangeAspect="1"/>
-          </p:cNvPicPr>
-          <p:nvPr/>
-        </p:nvPicPr>
-        <p:blipFill>
-          <a:blip r:embed="rId2">
-            <a:extLst>
-              <a:ext uri="{28A0092B-C50C-407E-A947-70E740481C1C}">
-                <a14:useLocalDpi xmlns:a14="http://schemas.microsoft.com/office/drawing/2010/main" val="0"/>
-              </a:ext>
-            </a:extLst>
-          </a:blip>
-          <a:srcRect/>
-          <a:stretch>
-            <a:fillRect/>
-          </a:stretch>
-        </p:blipFill>
-        <p:spPr bwMode="auto">
-          <a:xfrm>
-            <a:off x="11028362" y="19050"/>
-            <a:ext cx="1163638" cy="1144588"/>
-          </a:xfrm>
-          <a:prstGeom prst="rect">
-            <a:avLst/>
-          </a:prstGeom>
-          <a:noFill/>
-          <a:ln>
-            <a:noFill/>
-          </a:ln>
-          <a:extLst>
-            <a:ext uri="{909E8E84-426E-40DD-AFC4-6F175D3DCCD1}">
-              <a14:hiddenFill xmlns:a14="http://schemas.microsoft.com/office/drawing/2010/main">
-                <a:solidFill>
-                  <a:srgbClr val="FFFFFF"/>
-                </a:solidFill>
-              </a14:hiddenFill>
-            </a:ext>
-            <a:ext uri="{91240B29-F687-4F45-9708-019B960494DF}">
-              <a14:hiddenLine xmlns:a14="http://schemas.microsoft.com/office/drawing/2010/main" w="9525">
-                <a:solidFill>
-                  <a:srgbClr val="000000"/>
-                </a:solidFill>
-                <a:miter lim="800000"/>
-                <a:headEnd/>
-                <a:tailEnd/>
-              </a14:hiddenLine>
-            </a:ext>
-          </a:extLst>
-        </p:spPr>
-      </p:pic>
-      <p:sp>
-        <p:nvSpPr>
-          <p:cNvPr id="7" name="Date Placeholder 6"/>
-          <p:cNvSpPr>
-            <a:spLocks noGrp="1"/>
-          </p:cNvSpPr>
-          <p:nvPr>
-            <p:ph type="dt" sz="half" idx="10"/>
-          </p:nvPr>
-        </p:nvSpPr>
-        <p:spPr/>
-        <p:txBody>
-          <a:bodyPr/>
-          <a:lstStyle/>
-          <a:p>
-            <a:r>
-              <a:rPr>
-                <a:latin typeface="Times New Roman"/>
-                <a:cs typeface="Times New Roman"/>
-              </a:rPr>
-              <a:t>20-10-2026</a:t>
-            </a:r>
-          </a:p>
-        </p:txBody>
-      </p:sp>
-      <p:pic>
-        <p:nvPicPr>
-          <p:cNvPr id="8" name="Picture 7" descr="08_dashboard.jpg"/>
-          <p:cNvPicPr>
-            <a:picLocks noChangeAspect="1"/>
-          </p:cNvPicPr>
-          <p:nvPr/>
-        </p:nvPicPr>
-        <p:blipFill>
-          <a:blip r:embed="rId3"/>
-          <a:stretch>
-            <a:fillRect/>
-          </a:stretch>
-        </p:blipFill>
-        <p:spPr>
-          <a:xfrm>
-            <a:off x="838200" y="1700000"/>
-            <a:ext cx="5182800" cy="3239250"/>
-          </a:xfrm>
-          <a:prstGeom prst="rect">
-            <a:avLst/>
-          </a:prstGeom>
-          <a:ln w="9525">
-            <a:solidFill>
-              <a:srgbClr val="9AA0A6"/>
-            </a:solidFill>
-          </a:ln>
-        </p:spPr>
-      </p:pic>
-      <p:pic>
-        <p:nvPicPr>
-          <p:cNvPr id="9" name="Picture 8" descr="09_history.jpg"/>
-          <p:cNvPicPr>
-            <a:picLocks noChangeAspect="1"/>
-          </p:cNvPicPr>
-          <p:nvPr/>
-        </p:nvPicPr>
-        <p:blipFill>
-          <a:blip r:embed="rId4"/>
-          <a:stretch>
-            <a:fillRect/>
-          </a:stretch>
-        </p:blipFill>
-        <p:spPr>
-          <a:xfrm>
-            <a:off x="6171000" y="1700000"/>
-            <a:ext cx="5182800" cy="3239250"/>
-          </a:xfrm>
-          <a:prstGeom prst="rect">
-            <a:avLst/>
-          </a:prstGeom>
-          <a:ln w="9525">
-            <a:solidFill>
-              <a:srgbClr val="9AA0A6"/>
-            </a:solidFill>
-          </a:ln>
-        </p:spPr>
-      </p:pic>
-      <p:sp>
-        <p:nvSpPr>
-          <p:cNvPr id="10" name="TextBox 9"/>
-          <p:cNvSpPr txBox="1"/>
-          <p:nvPr/>
-        </p:nvSpPr>
-        <p:spPr>
-          <a:xfrm>
-            <a:off x="838200" y="5000000"/>
-            <a:ext cx="5182800" cy="400000"/>
-          </a:xfrm>
-          <a:prstGeom prst="rect">
-            <a:avLst/>
-          </a:prstGeom>
-          <a:noFill/>
-        </p:spPr>
-        <p:txBody>
-          <a:bodyPr wrap="square">
-            <a:spAutoFit/>
-          </a:bodyPr>
-          <a:lstStyle/>
-          <a:p>
-            <a:pPr indent="0" marL="0" algn="ctr">
-              <a:buNone/>
-              <a:spcBef>
-                <a:spcPts val="0"/>
-              </a:spcBef>
-            </a:pPr>
-            <a:r>
-              <a:rPr sz="1400" i="1">
-                <a:latin typeface="Times New Roman"/>
-                <a:cs typeface="Times New Roman"/>
-              </a:rPr>
-              <a:t>Dashboard: priority findings and recent scans</a:t>
-            </a:r>
-          </a:p>
-        </p:txBody>
-      </p:sp>
-      <p:sp>
-        <p:nvSpPr>
-          <p:cNvPr id="11" name="TextBox 10"/>
-          <p:cNvSpPr txBox="1"/>
-          <p:nvPr/>
-        </p:nvSpPr>
-        <p:spPr>
-          <a:xfrm>
-            <a:off x="6171000" y="5000000"/>
-            <a:ext cx="5182800" cy="400000"/>
-          </a:xfrm>
-          <a:prstGeom prst="rect">
-            <a:avLst/>
-          </a:prstGeom>
-          <a:noFill/>
-        </p:spPr>
-        <p:txBody>
-          <a:bodyPr wrap="square">
-            <a:spAutoFit/>
-          </a:bodyPr>
-          <a:lstStyle/>
-          <a:p>
-            <a:pPr indent="0" marL="0" algn="ctr">
-              <a:buNone/>
-              <a:spcBef>
-                <a:spcPts val="0"/>
-              </a:spcBef>
-            </a:pPr>
-            <a:r>
-              <a:rPr sz="1400" i="1">
-                <a:latin typeface="Times New Roman"/>
-                <a:cs typeface="Times New Roman"/>
-              </a:rPr>
-              <a:t>Scan history with search, filters and export</a:t>
-            </a:r>
-          </a:p>
-        </p:txBody>
-      </p:sp>
-    </p:spTree>
-  </p:cSld>
-  <p:clrMapOvr>
-    <a:masterClrMapping/>
-  </p:clrMapOvr>
-</p:sld>
-</file>
-
-<file path=ppt/slides/slide26.xml><?xml version="1.0" encoding="utf-8"?>
-<p:sld xmlns:a="http://schemas.openxmlformats.org/drawingml/2006/main" xmlns:p="http://schemas.openxmlformats.org/presentationml/2006/main" xmlns:r="http://schemas.openxmlformats.org/officeDocument/2006/relationships">
-  <p:cSld>
-    <p:spTree>
-      <p:nvGrpSpPr>
-        <p:cNvPr id="1" name=""/>
-        <p:cNvGrpSpPr/>
-        <p:nvPr/>
-      </p:nvGrpSpPr>
-      <p:grpSpPr/>
-      <p:sp>
-        <p:nvSpPr>
-          <p:cNvPr id="2" name="Title 1"/>
-          <p:cNvSpPr>
-            <a:spLocks noGrp="1"/>
-          </p:cNvSpPr>
-          <p:nvPr>
-            <p:ph type="title"/>
-          </p:nvPr>
-        </p:nvSpPr>
-        <p:spPr/>
-        <p:txBody>
-          <a:bodyPr/>
-          <a:lstStyle/>
-          <a:p>
-            <a:r>
-              <a:rPr b="1" sz="3200">
-                <a:solidFill>
-                  <a:srgbClr val="1F2A44"/>
-                </a:solidFill>
-                <a:latin typeface="Times New Roman"/>
-                <a:cs typeface="Times New Roman"/>
-              </a:rPr>
-              <a:t>Results: Snapshots of the Output (5/6)</a:t>
-            </a:r>
-          </a:p>
-        </p:txBody>
-      </p:sp>
-      <p:sp>
-        <p:nvSpPr>
-          <p:cNvPr id="4" name="Footer Placeholder 3"/>
-          <p:cNvSpPr>
-            <a:spLocks noGrp="1"/>
-          </p:cNvSpPr>
-          <p:nvPr>
-            <p:ph type="ftr" sz="quarter" idx="11"/>
-          </p:nvPr>
-        </p:nvSpPr>
-        <p:spPr>
-          <a:xfrm>
-            <a:off x="2700000" y="6356350"/>
-            <a:ext cx="6800000" cy="365125"/>
-          </a:xfrm>
-        </p:spPr>
-        <p:txBody>
-          <a:bodyPr/>
-          <a:lstStyle/>
-          <a:p>
-            <a:r>
-              <a:rPr sz="1100">
-                <a:latin typeface="Times New Roman"/>
-                <a:cs typeface="Times New Roman"/>
-              </a:rPr>
-              <a:t>ScamGuard: AI-Based Online Scam and Fraud Detection System   |   Department of CSE, BMSCE</a:t>
-            </a:r>
-          </a:p>
-        </p:txBody>
-      </p:sp>
-      <p:sp>
-        <p:nvSpPr>
-          <p:cNvPr id="5" name="Slide Number Placeholder 4"/>
-          <p:cNvSpPr>
-            <a:spLocks noGrp="1"/>
-          </p:cNvSpPr>
-          <p:nvPr>
-            <p:ph type="sldNum" sz="quarter" idx="12"/>
-          </p:nvPr>
-        </p:nvSpPr>
-        <p:spPr/>
-        <p:txBody>
-          <a:bodyPr/>
-          <a:lstStyle/>
-          <a:p>
-            <a:fld id="{840E0BF8-4B7D-46FA-B28A-DDF089F57DAF}" type="slidenum">
-              <a:rPr lang="en-IN" smtClean="0">
-                <a:latin typeface="Times New Roman"/>
-                <a:cs typeface="Times New Roman"/>
-              </a:rPr>
-              <a:t>6</a:t>
-            </a:fld>
-            <a:endParaRPr lang="en-IN">
-              <a:latin typeface="Times New Roman"/>
-              <a:cs typeface="Times New Roman"/>
-            </a:endParaRPr>
-          </a:p>
-        </p:txBody>
-      </p:sp>
-      <p:pic>
-        <p:nvPicPr>
-          <p:cNvPr id="6" name="Picture 1"/>
-          <p:cNvPicPr>
-            <a:picLocks noChangeAspect="1"/>
-          </p:cNvPicPr>
-          <p:nvPr/>
-        </p:nvPicPr>
-        <p:blipFill>
-          <a:blip r:embed="rId2">
-            <a:extLst>
-              <a:ext uri="{28A0092B-C50C-407E-A947-70E740481C1C}">
-                <a14:useLocalDpi xmlns:a14="http://schemas.microsoft.com/office/drawing/2010/main" val="0"/>
-              </a:ext>
-            </a:extLst>
-          </a:blip>
-          <a:srcRect/>
-          <a:stretch>
-            <a:fillRect/>
-          </a:stretch>
-        </p:blipFill>
-        <p:spPr bwMode="auto">
-          <a:xfrm>
-            <a:off x="11028362" y="19050"/>
-            <a:ext cx="1163638" cy="1144588"/>
-          </a:xfrm>
-          <a:prstGeom prst="rect">
-            <a:avLst/>
-          </a:prstGeom>
-          <a:noFill/>
-          <a:ln>
-            <a:noFill/>
-          </a:ln>
-          <a:extLst>
-            <a:ext uri="{909E8E84-426E-40DD-AFC4-6F175D3DCCD1}">
-              <a14:hiddenFill xmlns:a14="http://schemas.microsoft.com/office/drawing/2010/main">
-                <a:solidFill>
-                  <a:srgbClr val="FFFFFF"/>
-                </a:solidFill>
-              </a14:hiddenFill>
-            </a:ext>
-            <a:ext uri="{91240B29-F687-4F45-9708-019B960494DF}">
-              <a14:hiddenLine xmlns:a14="http://schemas.microsoft.com/office/drawing/2010/main" w="9525">
-                <a:solidFill>
-                  <a:srgbClr val="000000"/>
-                </a:solidFill>
-                <a:miter lim="800000"/>
-                <a:headEnd/>
-                <a:tailEnd/>
-              </a14:hiddenLine>
-            </a:ext>
-          </a:extLst>
-        </p:spPr>
-      </p:pic>
-      <p:sp>
-        <p:nvSpPr>
-          <p:cNvPr id="7" name="Date Placeholder 6"/>
-          <p:cNvSpPr>
-            <a:spLocks noGrp="1"/>
-          </p:cNvSpPr>
-          <p:nvPr>
-            <p:ph type="dt" sz="half" idx="10"/>
-          </p:nvPr>
-        </p:nvSpPr>
-        <p:spPr/>
-        <p:txBody>
-          <a:bodyPr/>
-          <a:lstStyle/>
-          <a:p>
-            <a:r>
-              <a:rPr>
-                <a:latin typeface="Times New Roman"/>
-                <a:cs typeface="Times New Roman"/>
-              </a:rPr>
-              <a:t>20-10-2026</a:t>
-            </a:r>
-          </a:p>
-        </p:txBody>
-      </p:sp>
-      <p:pic>
-        <p:nvPicPr>
           <p:cNvPr id="8" name="Picture 7" descr="10_analytics.jpg"/>
           <p:cNvPicPr>
             <a:picLocks noChangeAspect="1"/>
@@ -11642,8 +11038,8 @@
         </p:blipFill>
         <p:spPr>
           <a:xfrm>
-            <a:off x="838200" y="1700000"/>
-            <a:ext cx="5182800" cy="3239250"/>
+            <a:off x="2568000" y="1480000"/>
+            <a:ext cx="3328000" cy="2080000"/>
           </a:xfrm>
           <a:prstGeom prst="rect">
             <a:avLst/>
@@ -11655,9 +11051,47 @@
           </a:ln>
         </p:spPr>
       </p:pic>
+      <p:sp>
+        <p:nvSpPr>
+          <p:cNvPr id="9" name="TextBox 8"/>
+          <p:cNvSpPr txBox="1"/>
+          <p:nvPr/>
+        </p:nvSpPr>
+        <p:spPr>
+          <a:xfrm>
+            <a:off x="2568000" y="3580000"/>
+            <a:ext cx="3328000" cy="400000"/>
+          </a:xfrm>
+          <a:prstGeom prst="rect">
+            <a:avLst/>
+          </a:prstGeom>
+          <a:noFill/>
+        </p:spPr>
+        <p:txBody>
+          <a:bodyPr wrap="square">
+            <a:spAutoFit/>
+          </a:bodyPr>
+          <a:lstStyle/>
+          <a:p>
+            <a:pPr indent="0" marL="0" algn="ctr">
+              <a:buNone/>
+              <a:spcBef>
+                <a:spcPts val="0"/>
+              </a:spcBef>
+            </a:pPr>
+            <a:r>
+              <a:rPr sz="1300" i="1">
+                <a:latin typeface="Times New Roman"/>
+                <a:cs typeface="Times New Roman"/>
+              </a:rPr>
+              <a:t>Analytics: verdict share, score trend</a:t>
+            </a:r>
+          </a:p>
+        </p:txBody>
+      </p:sp>
       <p:pic>
         <p:nvPicPr>
-          <p:cNvPr id="9" name="Picture 8" descr="11_tools.jpg"/>
+          <p:cNvPr id="10" name="Picture 9" descr="11_tools.jpg"/>
           <p:cNvPicPr>
             <a:picLocks noChangeAspect="1"/>
           </p:cNvPicPr>
@@ -11671,8 +11105,8 @@
         </p:blipFill>
         <p:spPr>
           <a:xfrm>
-            <a:off x="6171000" y="1700000"/>
-            <a:ext cx="5182800" cy="3239250"/>
+            <a:off x="6296000" y="1480000"/>
+            <a:ext cx="3328000" cy="2080000"/>
           </a:xfrm>
           <a:prstGeom prst="rect">
             <a:avLst/>
@@ -11686,14 +11120,14 @@
       </p:pic>
       <p:sp>
         <p:nvSpPr>
-          <p:cNvPr id="10" name="TextBox 9"/>
+          <p:cNvPr id="11" name="TextBox 10"/>
           <p:cNvSpPr txBox="1"/>
           <p:nvPr/>
         </p:nvSpPr>
         <p:spPr>
           <a:xfrm>
-            <a:off x="838200" y="5000000"/>
-            <a:ext cx="5182800" cy="400000"/>
+            <a:off x="6296000" y="3580000"/>
+            <a:ext cx="3328000" cy="400000"/>
           </a:xfrm>
           <a:prstGeom prst="rect">
             <a:avLst/>
@@ -11713,255 +11147,33 @@
               </a:spcBef>
             </a:pPr>
             <a:r>
-              <a:rPr sz="1400" i="1">
-                <a:latin typeface="Times New Roman"/>
-                <a:cs typeface="Times New Roman"/>
-              </a:rPr>
-              <a:t>Analytics: verdict share and score trend</a:t>
-            </a:r>
-          </a:p>
-        </p:txBody>
-      </p:sp>
-      <p:sp>
-        <p:nvSpPr>
-          <p:cNvPr id="11" name="TextBox 10"/>
-          <p:cNvSpPr txBox="1"/>
-          <p:nvPr/>
-        </p:nvSpPr>
-        <p:spPr>
-          <a:xfrm>
-            <a:off x="6171000" y="5000000"/>
-            <a:ext cx="5182800" cy="400000"/>
-          </a:xfrm>
-          <a:prstGeom prst="rect">
-            <a:avLst/>
-          </a:prstGeom>
-          <a:noFill/>
-        </p:spPr>
-        <p:txBody>
-          <a:bodyPr wrap="square">
-            <a:spAutoFit/>
-          </a:bodyPr>
-          <a:lstStyle/>
-          <a:p>
-            <a:pPr indent="0" marL="0" algn="ctr">
-              <a:buNone/>
-              <a:spcBef>
-                <a:spcPts val="0"/>
-              </a:spcBef>
-            </a:pPr>
-            <a:r>
-              <a:rPr sz="1400" i="1">
-                <a:latin typeface="Times New Roman"/>
-                <a:cs typeface="Times New Roman"/>
-              </a:rPr>
-              <a:t>Safety tools: QR, before-you-pay, file check, chat timeline</a:t>
-            </a:r>
-          </a:p>
-        </p:txBody>
-      </p:sp>
-    </p:spTree>
-  </p:cSld>
-  <p:clrMapOvr>
-    <a:masterClrMapping/>
-  </p:clrMapOvr>
-</p:sld>
-</file>
-
-<file path=ppt/slides/slide27.xml><?xml version="1.0" encoding="utf-8"?>
-<p:sld xmlns:a="http://schemas.openxmlformats.org/drawingml/2006/main" xmlns:p="http://schemas.openxmlformats.org/presentationml/2006/main" xmlns:r="http://schemas.openxmlformats.org/officeDocument/2006/relationships">
-  <p:cSld>
-    <p:spTree>
-      <p:nvGrpSpPr>
-        <p:cNvPr id="1" name=""/>
-        <p:cNvGrpSpPr/>
-        <p:nvPr/>
-      </p:nvGrpSpPr>
-      <p:grpSpPr/>
-      <p:sp>
-        <p:nvSpPr>
-          <p:cNvPr id="2" name="Title 1"/>
-          <p:cNvSpPr>
-            <a:spLocks noGrp="1"/>
-          </p:cNvSpPr>
-          <p:nvPr>
-            <p:ph type="title"/>
-          </p:nvPr>
-        </p:nvSpPr>
-        <p:spPr/>
-        <p:txBody>
-          <a:bodyPr/>
-          <a:lstStyle/>
-          <a:p>
-            <a:r>
-              <a:rPr b="1" sz="3200">
-                <a:solidFill>
-                  <a:srgbClr val="1F2A44"/>
-                </a:solidFill>
-                <a:latin typeface="Times New Roman"/>
-                <a:cs typeface="Times New Roman"/>
-              </a:rPr>
-              <a:t>Results: Snapshots of the Output (6/6)</a:t>
-            </a:r>
-          </a:p>
-        </p:txBody>
-      </p:sp>
-      <p:sp>
-        <p:nvSpPr>
-          <p:cNvPr id="4" name="Footer Placeholder 3"/>
-          <p:cNvSpPr>
-            <a:spLocks noGrp="1"/>
-          </p:cNvSpPr>
-          <p:nvPr>
-            <p:ph type="ftr" sz="quarter" idx="11"/>
-          </p:nvPr>
-        </p:nvSpPr>
-        <p:spPr>
-          <a:xfrm>
-            <a:off x="2700000" y="6356350"/>
-            <a:ext cx="6800000" cy="365125"/>
-          </a:xfrm>
-        </p:spPr>
-        <p:txBody>
-          <a:bodyPr/>
-          <a:lstStyle/>
-          <a:p>
-            <a:r>
-              <a:rPr sz="1100">
-                <a:latin typeface="Times New Roman"/>
-                <a:cs typeface="Times New Roman"/>
-              </a:rPr>
-              <a:t>ScamGuard: AI-Based Online Scam and Fraud Detection System   |   Department of CSE, BMSCE</a:t>
-            </a:r>
-          </a:p>
-        </p:txBody>
-      </p:sp>
-      <p:sp>
-        <p:nvSpPr>
-          <p:cNvPr id="5" name="Slide Number Placeholder 4"/>
-          <p:cNvSpPr>
-            <a:spLocks noGrp="1"/>
-          </p:cNvSpPr>
-          <p:nvPr>
-            <p:ph type="sldNum" sz="quarter" idx="12"/>
-          </p:nvPr>
-        </p:nvSpPr>
-        <p:spPr/>
-        <p:txBody>
-          <a:bodyPr/>
-          <a:lstStyle/>
-          <a:p>
-            <a:fld id="{840E0BF8-4B7D-46FA-B28A-DDF089F57DAF}" type="slidenum">
-              <a:rPr lang="en-IN" smtClean="0">
-                <a:latin typeface="Times New Roman"/>
-                <a:cs typeface="Times New Roman"/>
-              </a:rPr>
-              <a:t>6</a:t>
-            </a:fld>
-            <a:endParaRPr lang="en-IN">
-              <a:latin typeface="Times New Roman"/>
-              <a:cs typeface="Times New Roman"/>
-            </a:endParaRPr>
+              <a:rPr sz="1300" i="1">
+                <a:latin typeface="Times New Roman"/>
+                <a:cs typeface="Times New Roman"/>
+              </a:rPr>
+              <a:t>Safety tools: QR, payment, file, chat</a:t>
+            </a:r>
           </a:p>
         </p:txBody>
       </p:sp>
       <p:pic>
         <p:nvPicPr>
-          <p:cNvPr id="6" name="Picture 1"/>
+          <p:cNvPr id="12" name="Picture 11" descr="12_simulator.jpg"/>
           <p:cNvPicPr>
             <a:picLocks noChangeAspect="1"/>
           </p:cNvPicPr>
           <p:nvPr/>
         </p:nvPicPr>
         <p:blipFill>
-          <a:blip r:embed="rId2">
-            <a:extLst>
-              <a:ext uri="{28A0092B-C50C-407E-A947-70E740481C1C}">
-                <a14:useLocalDpi xmlns:a14="http://schemas.microsoft.com/office/drawing/2010/main" val="0"/>
-              </a:ext>
-            </a:extLst>
-          </a:blip>
-          <a:srcRect/>
-          <a:stretch>
-            <a:fillRect/>
-          </a:stretch>
-        </p:blipFill>
-        <p:spPr bwMode="auto">
-          <a:xfrm>
-            <a:off x="11028362" y="19050"/>
-            <a:ext cx="1163638" cy="1144588"/>
-          </a:xfrm>
-          <a:prstGeom prst="rect">
-            <a:avLst/>
-          </a:prstGeom>
-          <a:noFill/>
-          <a:ln>
-            <a:noFill/>
-          </a:ln>
-          <a:extLst>
-            <a:ext uri="{909E8E84-426E-40DD-AFC4-6F175D3DCCD1}">
-              <a14:hiddenFill xmlns:a14="http://schemas.microsoft.com/office/drawing/2010/main">
-                <a:solidFill>
-                  <a:srgbClr val="FFFFFF"/>
-                </a:solidFill>
-              </a14:hiddenFill>
-            </a:ext>
-            <a:ext uri="{91240B29-F687-4F45-9708-019B960494DF}">
-              <a14:hiddenLine xmlns:a14="http://schemas.microsoft.com/office/drawing/2010/main" w="9525">
-                <a:solidFill>
-                  <a:srgbClr val="000000"/>
-                </a:solidFill>
-                <a:miter lim="800000"/>
-                <a:headEnd/>
-                <a:tailEnd/>
-              </a14:hiddenLine>
-            </a:ext>
-          </a:extLst>
-        </p:spPr>
-      </p:pic>
-      <p:sp>
-        <p:nvSpPr>
-          <p:cNvPr id="7" name="Date Placeholder 6"/>
-          <p:cNvSpPr>
-            <a:spLocks noGrp="1"/>
-          </p:cNvSpPr>
-          <p:nvPr>
-            <p:ph type="dt" sz="half" idx="10"/>
-          </p:nvPr>
-        </p:nvSpPr>
-        <p:spPr/>
-        <p:txBody>
-          <a:bodyPr/>
-          <a:lstStyle/>
-          <a:p>
-            <a:r>
-              <a:rPr>
-                <a:latin typeface="Times New Roman"/>
-                <a:cs typeface="Times New Roman"/>
-              </a:rPr>
-              <a:t>20-10-2026</a:t>
-            </a:r>
-          </a:p>
-        </p:txBody>
-      </p:sp>
-      <p:pic>
-        <p:nvPicPr>
-          <p:cNvPr id="8" name="Picture 7" descr="12_simulator.jpg"/>
-          <p:cNvPicPr>
-            <a:picLocks noChangeAspect="1"/>
-          </p:cNvPicPr>
-          <p:nvPr/>
-        </p:nvPicPr>
-        <p:blipFill>
-          <a:blip r:embed="rId3"/>
+          <a:blip r:embed="rId5"/>
           <a:stretch>
             <a:fillRect/>
           </a:stretch>
         </p:blipFill>
         <p:spPr>
           <a:xfrm>
-            <a:off x="2400000" y="1650000"/>
-            <a:ext cx="7400000" cy="4625000"/>
+            <a:off x="4432000" y="3930000"/>
+            <a:ext cx="3328000" cy="2080000"/>
           </a:xfrm>
           <a:prstGeom prst="rect">
             <a:avLst/>
@@ -11975,14 +11187,14 @@
       </p:pic>
       <p:sp>
         <p:nvSpPr>
-          <p:cNvPr id="9" name="TextBox 8"/>
+          <p:cNvPr id="13" name="TextBox 12"/>
           <p:cNvSpPr txBox="1"/>
           <p:nvPr/>
         </p:nvSpPr>
         <p:spPr>
           <a:xfrm>
-            <a:off x="838200" y="5900000"/>
-            <a:ext cx="10515600" cy="400000"/>
+            <a:off x="4432000" y="6030000"/>
+            <a:ext cx="3328000" cy="400000"/>
           </a:xfrm>
           <a:prstGeom prst="rect">
             <a:avLst/>
@@ -12002,287 +11214,11 @@
               </a:spcBef>
             </a:pPr>
             <a:r>
-              <a:rPr sz="1400" i="1">
-                <a:latin typeface="Times New Roman"/>
-                <a:cs typeface="Times New Roman"/>
-              </a:rPr>
-              <a:t>Scam simulator: practice messages to learn the common tricks</a:t>
-            </a:r>
-          </a:p>
-        </p:txBody>
-      </p:sp>
-    </p:spTree>
-  </p:cSld>
-  <p:clrMapOvr>
-    <a:masterClrMapping/>
-  </p:clrMapOvr>
-</p:sld>
-</file>
-
-<file path=ppt/slides/slide28.xml><?xml version="1.0" encoding="utf-8"?>
-<p:sld xmlns:a="http://schemas.openxmlformats.org/drawingml/2006/main" xmlns:p="http://schemas.openxmlformats.org/presentationml/2006/main" xmlns:r="http://schemas.openxmlformats.org/officeDocument/2006/relationships">
-  <p:cSld>
-    <p:spTree>
-      <p:nvGrpSpPr>
-        <p:cNvPr id="1" name=""/>
-        <p:cNvGrpSpPr/>
-        <p:nvPr/>
-      </p:nvGrpSpPr>
-      <p:grpSpPr/>
-      <p:sp>
-        <p:nvSpPr>
-          <p:cNvPr id="2" name="Title 1"/>
-          <p:cNvSpPr>
-            <a:spLocks noGrp="1"/>
-          </p:cNvSpPr>
-          <p:nvPr>
-            <p:ph type="title"/>
-          </p:nvPr>
-        </p:nvSpPr>
-        <p:spPr/>
-        <p:txBody>
-          <a:bodyPr/>
-          <a:lstStyle/>
-          <a:p>
-            <a:r>
-              <a:rPr b="1" sz="3200">
-                <a:solidFill>
-                  <a:srgbClr val="1F2A44"/>
-                </a:solidFill>
-                <a:latin typeface="Times New Roman"/>
-                <a:cs typeface="Times New Roman"/>
-              </a:rPr>
-              <a:t>References (contd.)</a:t>
-            </a:r>
-          </a:p>
-        </p:txBody>
-      </p:sp>
-      <p:sp>
-        <p:nvSpPr>
-          <p:cNvPr id="3" name="Content Placeholder 2"/>
-          <p:cNvSpPr>
-            <a:spLocks noGrp="1"/>
-          </p:cNvSpPr>
-          <p:nvPr>
-            <p:ph idx="1"/>
-          </p:nvPr>
-        </p:nvSpPr>
-        <p:spPr/>
-        <p:txBody>
-          <a:bodyPr wrap="square"/>
-          <a:lstStyle/>
-          <a:p>
-            <a:pPr indent="-457200" marL="457200">
-              <a:buNone/>
-              <a:spcBef>
-                <a:spcPts val="800"/>
-              </a:spcBef>
-            </a:pPr>
-            <a:r>
-              <a:rPr sz="1500">
-                <a:latin typeface="Times New Roman"/>
-                <a:cs typeface="Times New Roman"/>
-              </a:rPr>
-              <a:t>[7]  K. Lee et al., "Deduplicating training data makes language models better," in Proc. ACL, 2022, pp. 8424-8445, doi: 10.18653/v1/2022.acl-long.577.</a:t>
-            </a:r>
-            <a:endParaRPr lang="en-IN"/>
-          </a:p>
-          <a:p>
-            <a:pPr indent="-457200" marL="457200">
-              <a:buNone/>
-              <a:spcBef>
-                <a:spcPts val="800"/>
-              </a:spcBef>
-            </a:pPr>
-            <a:r>
-              <a:rPr sz="1500">
-                <a:latin typeface="Times New Roman"/>
-                <a:cs typeface="Times New Roman"/>
-              </a:rPr>
-              <a:t>[8]  S. Kapoor and A. Narayanan, "Leakage and the reproducibility crisis in machine-learning-based science," Patterns, 2023, doi: 10.1016/j.patter.2023.100804.</a:t>
-            </a:r>
-          </a:p>
-          <a:p>
-            <a:pPr indent="-457200" marL="457200">
-              <a:buNone/>
-              <a:spcBef>
-                <a:spcPts val="800"/>
-              </a:spcBef>
-            </a:pPr>
-            <a:r>
-              <a:rPr sz="1500">
-                <a:latin typeface="Times New Roman"/>
-                <a:cs typeface="Times New Roman"/>
-              </a:rPr>
-              <a:t>[9]  A. Z. Broder, "On the resemblance and containment of documents," in Proc. Compression and Complexity of SEQUENCES, 1997, doi: 10.1109/SEQUEN.1997.666900.</a:t>
-            </a:r>
-          </a:p>
-          <a:p>
-            <a:pPr indent="-457200" marL="457200">
-              <a:buNone/>
-              <a:spcBef>
-                <a:spcPts val="800"/>
-              </a:spcBef>
-            </a:pPr>
-            <a:r>
-              <a:rPr sz="1500">
-                <a:latin typeface="Times New Roman"/>
-                <a:cs typeface="Times New Roman"/>
-              </a:rPr>
-              <a:t>[10]  G. Salton and C. Buckley, "Term-weighting approaches in automatic text retrieval," Inf. Process. Manage., vol. 24, no. 5, pp. 513-523, 1988.</a:t>
-            </a:r>
-          </a:p>
-          <a:p>
-            <a:pPr indent="-457200" marL="457200">
-              <a:buNone/>
-              <a:spcBef>
-                <a:spcPts val="800"/>
-              </a:spcBef>
-            </a:pPr>
-            <a:r>
-              <a:rPr sz="1500">
-                <a:latin typeface="Times New Roman"/>
-                <a:cs typeface="Times New Roman"/>
-              </a:rPr>
-              <a:t>[11]  F. Pedregosa et al., "Scikit-learn: Machine learning in Python," J. Mach. Learn. Res., vol. 12, pp. 2825-2830, 2011.</a:t>
-            </a:r>
-          </a:p>
-        </p:txBody>
-      </p:sp>
-      <p:sp>
-        <p:nvSpPr>
-          <p:cNvPr id="4" name="Footer Placeholder 3"/>
-          <p:cNvSpPr>
-            <a:spLocks noGrp="1"/>
-          </p:cNvSpPr>
-          <p:nvPr>
-            <p:ph type="ftr" sz="quarter" idx="11"/>
-          </p:nvPr>
-        </p:nvSpPr>
-        <p:spPr>
-          <a:xfrm>
-            <a:off x="2700000" y="6356350"/>
-            <a:ext cx="6800000" cy="365125"/>
-          </a:xfrm>
-        </p:spPr>
-        <p:txBody>
-          <a:bodyPr/>
-          <a:lstStyle/>
-          <a:p>
-            <a:r>
-              <a:rPr sz="1100">
-                <a:latin typeface="Times New Roman"/>
-                <a:cs typeface="Times New Roman"/>
-              </a:rPr>
-              <a:t>ScamGuard: AI-Based Online Scam and Fraud Detection System   |   Department of CSE, BMSCE</a:t>
-            </a:r>
-          </a:p>
-        </p:txBody>
-      </p:sp>
-      <p:sp>
-        <p:nvSpPr>
-          <p:cNvPr id="5" name="Slide Number Placeholder 4"/>
-          <p:cNvSpPr>
-            <a:spLocks noGrp="1"/>
-          </p:cNvSpPr>
-          <p:nvPr>
-            <p:ph type="sldNum" sz="quarter" idx="12"/>
-          </p:nvPr>
-        </p:nvSpPr>
-        <p:spPr/>
-        <p:txBody>
-          <a:bodyPr/>
-          <a:lstStyle/>
-          <a:p>
-            <a:fld id="{840E0BF8-4B7D-46FA-B28A-DDF089F57DAF}" type="slidenum">
-              <a:rPr lang="en-IN" smtClean="0">
-                <a:latin typeface="Times New Roman"/>
-                <a:cs typeface="Times New Roman"/>
-              </a:rPr>
-              <a:t>6</a:t>
-            </a:fld>
-            <a:endParaRPr lang="en-IN">
-              <a:latin typeface="Times New Roman"/>
-              <a:cs typeface="Times New Roman"/>
-            </a:endParaRPr>
-          </a:p>
-        </p:txBody>
-      </p:sp>
-      <p:pic>
-        <p:nvPicPr>
-          <p:cNvPr id="6" name="Picture 1"/>
-          <p:cNvPicPr>
-            <a:picLocks noChangeAspect="1"/>
-          </p:cNvPicPr>
-          <p:nvPr/>
-        </p:nvPicPr>
-        <p:blipFill>
-          <a:blip r:embed="rId2">
-            <a:extLst>
-              <a:ext uri="{28A0092B-C50C-407E-A947-70E740481C1C}">
-                <a14:useLocalDpi xmlns:a14="http://schemas.microsoft.com/office/drawing/2010/main" val="0"/>
-              </a:ext>
-            </a:extLst>
-          </a:blip>
-          <a:srcRect/>
-          <a:stretch>
-            <a:fillRect/>
-          </a:stretch>
-        </p:blipFill>
-        <p:spPr bwMode="auto">
-          <a:xfrm>
-            <a:off x="11028362" y="19050"/>
-            <a:ext cx="1163638" cy="1144588"/>
-          </a:xfrm>
-          <a:prstGeom prst="rect">
-            <a:avLst/>
-          </a:prstGeom>
-          <a:noFill/>
-          <a:ln>
-            <a:noFill/>
-          </a:ln>
-          <a:extLst>
-            <a:ext uri="{909E8E84-426E-40DD-AFC4-6F175D3DCCD1}">
-              <a14:hiddenFill xmlns:a14="http://schemas.microsoft.com/office/drawing/2010/main">
-                <a:solidFill>
-                  <a:srgbClr val="FFFFFF"/>
-                </a:solidFill>
-              </a14:hiddenFill>
-            </a:ext>
-            <a:ext uri="{91240B29-F687-4F45-9708-019B960494DF}">
-              <a14:hiddenLine xmlns:a14="http://schemas.microsoft.com/office/drawing/2010/main" w="9525">
-                <a:solidFill>
-                  <a:srgbClr val="000000"/>
-                </a:solidFill>
-                <a:miter lim="800000"/>
-                <a:headEnd/>
-                <a:tailEnd/>
-              </a14:hiddenLine>
-            </a:ext>
-          </a:extLst>
-        </p:spPr>
-      </p:pic>
-      <p:sp>
-        <p:nvSpPr>
-          <p:cNvPr id="7" name="Date Placeholder 6"/>
-          <p:cNvSpPr>
-            <a:spLocks noGrp="1"/>
-          </p:cNvSpPr>
-          <p:nvPr>
-            <p:ph type="dt" sz="half" idx="10"/>
-          </p:nvPr>
-        </p:nvSpPr>
-        <p:spPr/>
-        <p:txBody>
-          <a:bodyPr/>
-          <a:lstStyle/>
-          <a:p>
-            <a:r>
-              <a:rPr>
-                <a:latin typeface="Times New Roman"/>
-                <a:cs typeface="Times New Roman"/>
-              </a:rPr>
-              <a:t>20-10-2026</a:t>
+              <a:rPr sz="1300" i="1">
+                <a:latin typeface="Times New Roman"/>
+                <a:cs typeface="Times New Roman"/>
+              </a:rPr>
+              <a:t>Scam simulator for practice</a:t>
             </a:r>
           </a:p>
         </p:txBody>

</xml_diff>

<commit_message>
Presentation: larger, sharper snapshots; conclusion and future enhancements on one slide
</commit_message>
<xml_diff>
--- a/docs/presentation/ScamGuard_PP2_Presentation.pptx
+++ b/docs/presentation/ScamGuard_PP2_Presentation.pptx
@@ -23,8 +23,8 @@
     <p:sldId id="279" r:id="rId27"/>
     <p:sldId id="280" r:id="rId28"/>
     <p:sldId id="281" r:id="rId29"/>
+    <p:sldId id="282" r:id="rId30"/>
     <p:sldId id="271" r:id="rId12"/>
-    <p:sldId id="270" r:id="rId13"/>
     <p:sldId id="272" r:id="rId14"/>
     <p:sldId id="273" r:id="rId15"/>
     <p:sldId id="264" r:id="rId16"/>
@@ -5172,94 +5172,7 @@
                 <a:latin typeface="Times New Roman"/>
                 <a:cs typeface="Times New Roman"/>
               </a:rPr>
-              <a:t>Conclusion</a:t>
-            </a:r>
-          </a:p>
-        </p:txBody>
-      </p:sp>
-      <p:sp>
-        <p:nvSpPr>
-          <p:cNvPr id="3" name="Content Placeholder 2"/>
-          <p:cNvSpPr>
-            <a:spLocks noGrp="1"/>
-          </p:cNvSpPr>
-          <p:nvPr>
-            <p:ph idx="1"/>
-          </p:nvPr>
-        </p:nvSpPr>
-        <p:spPr/>
-        <p:txBody>
-          <a:bodyPr wrap="square"/>
-          <a:lstStyle/>
-          <a:p>
-            <a:pPr>
-              <a:spcBef>
-                <a:spcPts val="1000"/>
-              </a:spcBef>
-            </a:pPr>
-            <a:r>
-              <a:rPr sz="2000">
-                <a:latin typeface="Times New Roman"/>
-                <a:cs typeface="Times New Roman"/>
-              </a:rPr>
-              <a:t>Built ScamGuard-IN-2026: 11,399 Indian SMS with audited labels and a campaign-aware split</a:t>
-            </a:r>
-            <a:endParaRPr lang="en-IN"/>
-          </a:p>
-          <a:p>
-            <a:pPr>
-              <a:spcBef>
-                <a:spcPts val="1000"/>
-              </a:spcBef>
-            </a:pPr>
-            <a:r>
-              <a:rPr sz="2000">
-                <a:latin typeface="Times New Roman"/>
-                <a:cs typeface="Times New Roman"/>
-              </a:rPr>
-              <a:t>Label quality matters more than the model: report labels 34.0% false alarms, audited labels 2.6%</a:t>
-            </a:r>
-          </a:p>
-          <a:p>
-            <a:pPr>
-              <a:spcBef>
-                <a:spcPts val="1000"/>
-              </a:spcBef>
-            </a:pPr>
-            <a:r>
-              <a:rPr sz="2000">
-                <a:latin typeface="Times New Roman"/>
-                <a:cs typeface="Times New Roman"/>
-              </a:rPr>
-              <a:t>Deployed system on 1,874 real messages from unseen campaigns: 97.1% accuracy, 98.2% precision, 97.2% recall, 3.2% false alarms</a:t>
-            </a:r>
-          </a:p>
-          <a:p>
-            <a:pPr>
-              <a:spcBef>
-                <a:spcPts val="1000"/>
-              </a:spcBef>
-            </a:pPr>
-            <a:r>
-              <a:rPr sz="2000">
-                <a:latin typeface="Times New Roman"/>
-                <a:cs typeface="Times New Roman"/>
-              </a:rPr>
-              <a:t>Campaign split gives an honest false-alarm estimate; intent rules serve explanation rather than accuracy</a:t>
-            </a:r>
-          </a:p>
-          <a:p>
-            <a:pPr>
-              <a:spcBef>
-                <a:spcPts val="1000"/>
-              </a:spcBef>
-            </a:pPr>
-            <a:r>
-              <a:rPr sz="2000">
-                <a:latin typeface="Times New Roman"/>
-                <a:cs typeface="Times New Roman"/>
-              </a:rPr>
-              <a:t>Working web application: Hindi support, phrase-level explanations, safety tools, history and analytics, under 4 ms per message</a:t>
+              <a:t>Conclusion and Future Enhancements</a:t>
             </a:r>
           </a:p>
         </p:txBody>
@@ -5402,299 +5315,314 @@
           </a:p>
         </p:txBody>
       </p:sp>
-    </p:spTree>
-    <p:extLst>
-      <p:ext uri="{BB962C8B-B14F-4D97-AF65-F5344CB8AC3E}">
-        <p14:creationId xmlns:p14="http://schemas.microsoft.com/office/powerpoint/2010/main" val="586583528"/>
-      </p:ext>
-    </p:extLst>
-  </p:cSld>
-  <p:clrMapOvr>
-    <a:masterClrMapping/>
-  </p:clrMapOvr>
-</p:sld>
-</file>
-
-<file path=ppt/slides/slide12.xml><?xml version="1.0" encoding="utf-8"?>
-<p:sld xmlns:a="http://schemas.openxmlformats.org/drawingml/2006/main" xmlns:r="http://schemas.openxmlformats.org/officeDocument/2006/relationships" xmlns:p="http://schemas.openxmlformats.org/presentationml/2006/main">
-  <p:cSld>
-    <p:spTree>
-      <p:nvGrpSpPr>
-        <p:cNvPr id="1" name=""/>
-        <p:cNvGrpSpPr/>
-        <p:nvPr/>
-      </p:nvGrpSpPr>
-      <p:grpSpPr>
-        <a:xfrm>
-          <a:off x="0" y="0"/>
-          <a:ext cx="0" cy="0"/>
-          <a:chOff x="0" y="0"/>
-          <a:chExt cx="0" cy="0"/>
-        </a:xfrm>
-      </p:grpSpPr>
-      <p:sp>
-        <p:nvSpPr>
-          <p:cNvPr id="2" name="Title 1"/>
-          <p:cNvSpPr>
-            <a:spLocks noGrp="1"/>
-          </p:cNvSpPr>
-          <p:nvPr>
-            <p:ph type="title"/>
-          </p:nvPr>
-        </p:nvSpPr>
-        <p:spPr/>
-        <p:txBody>
-          <a:bodyPr/>
-          <a:lstStyle/>
-          <a:p>
-            <a:r>
-              <a:rPr b="1" sz="3200">
-                <a:solidFill>
-                  <a:srgbClr val="1F2A44"/>
-                </a:solidFill>
-                <a:latin typeface="Times New Roman"/>
-                <a:cs typeface="Times New Roman"/>
-              </a:rPr>
-              <a:t>Future Enhancements</a:t>
-            </a:r>
-          </a:p>
-        </p:txBody>
-      </p:sp>
-      <p:sp>
-        <p:nvSpPr>
-          <p:cNvPr id="3" name="Content Placeholder 2"/>
-          <p:cNvSpPr>
-            <a:spLocks noGrp="1"/>
-          </p:cNvSpPr>
-          <p:nvPr>
-            <p:ph idx="1"/>
-          </p:nvPr>
-        </p:nvSpPr>
-        <p:spPr/>
-        <p:txBody>
-          <a:bodyPr wrap="square"/>
-          <a:lstStyle/>
-          <a:p>
-            <a:pPr>
+      <p:sp>
+        <p:nvSpPr>
+          <p:cNvPr id="8" name="Rectangle 7"/>
+          <p:cNvSpPr/>
+          <p:nvPr/>
+        </p:nvSpPr>
+        <p:spPr>
+          <a:xfrm>
+            <a:off x="838200" y="1650000"/>
+            <a:ext cx="5107800" cy="450000"/>
+          </a:xfrm>
+          <a:prstGeom prst="rect">
+            <a:avLst/>
+          </a:prstGeom>
+          <a:solidFill>
+            <a:srgbClr val="1F2A44"/>
+          </a:solidFill>
+          <a:ln>
+            <a:noFill/>
+          </a:ln>
+        </p:spPr>
+        <p:style>
+          <a:lnRef idx="1">
+            <a:schemeClr val="accent1"/>
+          </a:lnRef>
+          <a:fillRef idx="3">
+            <a:schemeClr val="accent1"/>
+          </a:fillRef>
+          <a:effectRef idx="2">
+            <a:schemeClr val="accent1"/>
+          </a:effectRef>
+          <a:fontRef idx="minor">
+            <a:schemeClr val="lt1"/>
+          </a:fontRef>
+        </p:style>
+        <p:txBody>
+          <a:bodyPr rtlCol="0" anchor="ctr" wrap="square"/>
+          <a:lstStyle/>
+          <a:p>
+            <a:pPr algn="ctr" indent="0" marL="0">
+              <a:buNone/>
               <a:spcBef>
-                <a:spcPts val="1000"/>
+                <a:spcPts val="0"/>
               </a:spcBef>
             </a:pPr>
             <a:r>
-              <a:rPr sz="2000">
-                <a:latin typeface="Times New Roman"/>
-                <a:cs typeface="Times New Roman"/>
-              </a:rPr>
-              <a:t>Team-contributed 2026 SMS as a larger real test set for the newest scam types</a:t>
-            </a:r>
-            <a:endParaRPr lang="en-IN"/>
-          </a:p>
-          <a:p>
-            <a:pPr>
-              <a:spcBef>
-                <a:spcPts val="1000"/>
-              </a:spcBef>
-            </a:pPr>
-            <a:r>
-              <a:rPr sz="2000">
-                <a:latin typeface="Times New Roman"/>
-                <a:cs typeface="Times New Roman"/>
-              </a:rPr>
-              <a:t>Second annotator for the label audit and inter-annotator agreement</a:t>
-            </a:r>
-          </a:p>
-          <a:p>
-            <a:pPr>
-              <a:spcBef>
-                <a:spcPts val="1000"/>
-              </a:spcBef>
-            </a:pPr>
-            <a:r>
-              <a:rPr sz="2000">
-                <a:latin typeface="Times New Roman"/>
-                <a:cs typeface="Times New Roman"/>
-              </a:rPr>
-              <a:t>Kannada, Tamil, Telugu and other Indian languages</a:t>
-            </a:r>
-          </a:p>
-          <a:p>
-            <a:pPr>
-              <a:spcBef>
-                <a:spcPts val="1000"/>
-              </a:spcBef>
-            </a:pPr>
-            <a:r>
-              <a:rPr sz="2000">
-                <a:latin typeface="Times New Roman"/>
-                <a:cs typeface="Times New Roman"/>
-              </a:rPr>
-              <a:t>Tests against adaptive and LLM-paraphrased scams</a:t>
-            </a:r>
-          </a:p>
-          <a:p>
-            <a:pPr>
-              <a:spcBef>
-                <a:spcPts val="1000"/>
-              </a:spcBef>
-            </a:pPr>
-            <a:r>
-              <a:rPr sz="2000">
-                <a:latin typeface="Times New Roman"/>
-                <a:cs typeface="Times New Roman"/>
-              </a:rPr>
-              <a:t>Small transformer models under the same campaign split</a:t>
-            </a:r>
-          </a:p>
-          <a:p>
-            <a:pPr>
-              <a:spcBef>
-                <a:spcPts val="1000"/>
-              </a:spcBef>
-            </a:pPr>
-            <a:r>
-              <a:rPr sz="2000">
-                <a:latin typeface="Times New Roman"/>
-                <a:cs typeface="Times New Roman"/>
-              </a:rPr>
-              <a:t>Android share-to-check, so users need not copy the message</a:t>
-            </a:r>
-          </a:p>
-        </p:txBody>
-      </p:sp>
-      <p:sp>
-        <p:nvSpPr>
-          <p:cNvPr id="4" name="Footer Placeholder 3"/>
-          <p:cNvSpPr>
-            <a:spLocks noGrp="1"/>
-          </p:cNvSpPr>
-          <p:nvPr>
-            <p:ph type="ftr" sz="quarter" idx="11"/>
-          </p:nvPr>
+              <a:rPr sz="2000" b="1">
+                <a:solidFill>
+                  <a:srgbClr val="FFFFFF"/>
+                </a:solidFill>
+                <a:latin typeface="Times New Roman"/>
+                <a:cs typeface="Times New Roman"/>
+              </a:rPr>
+              <a:t>Conclusion</a:t>
+            </a:r>
+          </a:p>
+        </p:txBody>
+      </p:sp>
+      <p:sp>
+        <p:nvSpPr>
+          <p:cNvPr id="9" name="TextBox 8"/>
+          <p:cNvSpPr txBox="1"/>
+          <p:nvPr/>
         </p:nvSpPr>
         <p:spPr>
           <a:xfrm>
-            <a:off x="2700000" y="6356350"/>
-            <a:ext cx="6800000" cy="365125"/>
-          </a:xfrm>
-        </p:spPr>
-        <p:txBody>
-          <a:bodyPr/>
-          <a:lstStyle/>
-          <a:p>
-            <a:r>
-              <a:rPr sz="1100">
-                <a:latin typeface="Times New Roman"/>
-                <a:cs typeface="Times New Roman"/>
-              </a:rPr>
-              <a:t>ScamGuard: AI-Based Online Scam and Fraud Detection System   |   Department of CSE, BMSCE</a:t>
-            </a:r>
-          </a:p>
-        </p:txBody>
-      </p:sp>
-      <p:sp>
-        <p:nvSpPr>
-          <p:cNvPr id="5" name="Slide Number Placeholder 4"/>
-          <p:cNvSpPr>
-            <a:spLocks noGrp="1"/>
-          </p:cNvSpPr>
-          <p:nvPr>
-            <p:ph type="sldNum" sz="quarter" idx="12"/>
-          </p:nvPr>
-        </p:nvSpPr>
-        <p:spPr/>
-        <p:txBody>
-          <a:bodyPr/>
-          <a:lstStyle/>
-          <a:p>
-            <a:fld id="{840E0BF8-4B7D-46FA-B28A-DDF089F57DAF}" type="slidenum">
-              <a:rPr lang="en-IN" smtClean="0">
-                <a:latin typeface="Times New Roman"/>
-                <a:cs typeface="Times New Roman"/>
-              </a:rPr>
-              <a:t>12</a:t>
-            </a:fld>
-            <a:endParaRPr lang="en-IN">
-              <a:latin typeface="Times New Roman"/>
-              <a:cs typeface="Times New Roman"/>
-            </a:endParaRPr>
-          </a:p>
-        </p:txBody>
-      </p:sp>
-      <p:pic>
-        <p:nvPicPr>
-          <p:cNvPr id="6" name="Picture 1"/>
-          <p:cNvPicPr>
-            <a:picLocks noChangeAspect="1"/>
-          </p:cNvPicPr>
-          <p:nvPr/>
-        </p:nvPicPr>
-        <p:blipFill>
-          <a:blip r:embed="rId2">
-            <a:extLst>
-              <a:ext uri="{28A0092B-C50C-407E-A947-70E740481C1C}">
-                <a14:useLocalDpi xmlns:a14="http://schemas.microsoft.com/office/drawing/2010/main" val="0"/>
-              </a:ext>
-            </a:extLst>
-          </a:blip>
-          <a:srcRect/>
-          <a:stretch>
-            <a:fillRect/>
-          </a:stretch>
-        </p:blipFill>
-        <p:spPr bwMode="auto">
-          <a:xfrm>
-            <a:off x="11028362" y="19050"/>
-            <a:ext cx="1163638" cy="1144588"/>
+            <a:off x="838200" y="2200000"/>
+            <a:ext cx="5107800" cy="4000000"/>
           </a:xfrm>
           <a:prstGeom prst="rect">
             <a:avLst/>
           </a:prstGeom>
           <a:noFill/>
+        </p:spPr>
+        <p:txBody>
+          <a:bodyPr wrap="square">
+            <a:spAutoFit/>
+          </a:bodyPr>
+          <a:lstStyle/>
+          <a:p>
+            <a:pPr marL="228600" indent="-228600">
+              <a:spcBef>
+                <a:spcPts val="800"/>
+              </a:spcBef>
+              <a:buChar char="•"/>
+            </a:pPr>
+            <a:r>
+              <a:rPr sz="1700">
+                <a:latin typeface="Times New Roman"/>
+                <a:cs typeface="Times New Roman"/>
+              </a:rPr>
+              <a:t>ScamGuard-IN-2026: 11,399 Indian SMS, audited labels, campaign-aware split</a:t>
+            </a:r>
+          </a:p>
+          <a:p>
+            <a:pPr marL="228600" indent="-228600">
+              <a:spcBef>
+                <a:spcPts val="800"/>
+              </a:spcBef>
+              <a:buChar char="•"/>
+            </a:pPr>
+            <a:r>
+              <a:rPr sz="1700">
+                <a:latin typeface="Times New Roman"/>
+                <a:cs typeface="Times New Roman"/>
+              </a:rPr>
+              <a:t>Label quality matters most: report labels 34.0% false alarms, audited labels 2.6%</a:t>
+            </a:r>
+          </a:p>
+          <a:p>
+            <a:pPr marL="228600" indent="-228600">
+              <a:spcBef>
+                <a:spcPts val="800"/>
+              </a:spcBef>
+              <a:buChar char="•"/>
+            </a:pPr>
+            <a:r>
+              <a:rPr sz="1700">
+                <a:latin typeface="Times New Roman"/>
+                <a:cs typeface="Times New Roman"/>
+              </a:rPr>
+              <a:t>Deployed system on 1,874 unseen-campaign messages: 97.1% accuracy, 98.2% precision, 97.2% recall, 3.2% false alarms</a:t>
+            </a:r>
+          </a:p>
+          <a:p>
+            <a:pPr marL="228600" indent="-228600">
+              <a:spcBef>
+                <a:spcPts val="800"/>
+              </a:spcBef>
+              <a:buChar char="•"/>
+            </a:pPr>
+            <a:r>
+              <a:rPr sz="1700">
+                <a:latin typeface="Times New Roman"/>
+                <a:cs typeface="Times New Roman"/>
+              </a:rPr>
+              <a:t>Explainable web application with Hindi support, under 4 ms per message</a:t>
+            </a:r>
+          </a:p>
+        </p:txBody>
+      </p:sp>
+      <p:sp>
+        <p:nvSpPr>
+          <p:cNvPr id="10" name="Rectangle 9"/>
+          <p:cNvSpPr/>
+          <p:nvPr/>
+        </p:nvSpPr>
+        <p:spPr>
+          <a:xfrm>
+            <a:off x="6246000" y="1650000"/>
+            <a:ext cx="5107800" cy="450000"/>
+          </a:xfrm>
+          <a:prstGeom prst="rect">
+            <a:avLst/>
+          </a:prstGeom>
+          <a:solidFill>
+            <a:srgbClr val="1F2A44"/>
+          </a:solidFill>
           <a:ln>
             <a:noFill/>
           </a:ln>
-          <a:extLst>
-            <a:ext uri="{909E8E84-426E-40DD-AFC4-6F175D3DCCD1}">
-              <a14:hiddenFill xmlns:a14="http://schemas.microsoft.com/office/drawing/2010/main">
+        </p:spPr>
+        <p:style>
+          <a:lnRef idx="1">
+            <a:schemeClr val="accent1"/>
+          </a:lnRef>
+          <a:fillRef idx="3">
+            <a:schemeClr val="accent1"/>
+          </a:fillRef>
+          <a:effectRef idx="2">
+            <a:schemeClr val="accent1"/>
+          </a:effectRef>
+          <a:fontRef idx="minor">
+            <a:schemeClr val="lt1"/>
+          </a:fontRef>
+        </p:style>
+        <p:txBody>
+          <a:bodyPr rtlCol="0" anchor="ctr" wrap="square"/>
+          <a:lstStyle/>
+          <a:p>
+            <a:pPr algn="ctr" indent="0" marL="0">
+              <a:buNone/>
+              <a:spcBef>
+                <a:spcPts val="0"/>
+              </a:spcBef>
+            </a:pPr>
+            <a:r>
+              <a:rPr sz="2000" b="1">
                 <a:solidFill>
                   <a:srgbClr val="FFFFFF"/>
                 </a:solidFill>
-              </a14:hiddenFill>
-            </a:ext>
-            <a:ext uri="{91240B29-F687-4F45-9708-019B960494DF}">
-              <a14:hiddenLine xmlns:a14="http://schemas.microsoft.com/office/drawing/2010/main" w="9525">
-                <a:solidFill>
-                  <a:srgbClr val="000000"/>
-                </a:solidFill>
-                <a:miter lim="800000"/>
-                <a:headEnd/>
-                <a:tailEnd/>
-              </a14:hiddenLine>
-            </a:ext>
-          </a:extLst>
+                <a:latin typeface="Times New Roman"/>
+                <a:cs typeface="Times New Roman"/>
+              </a:rPr>
+              <a:t>Future Enhancements</a:t>
+            </a:r>
+          </a:p>
+        </p:txBody>
+      </p:sp>
+      <p:sp>
+        <p:nvSpPr>
+          <p:cNvPr id="11" name="TextBox 10"/>
+          <p:cNvSpPr txBox="1"/>
+          <p:nvPr/>
+        </p:nvSpPr>
+        <p:spPr>
+          <a:xfrm>
+            <a:off x="6246000" y="2200000"/>
+            <a:ext cx="5107800" cy="4000000"/>
+          </a:xfrm>
+          <a:prstGeom prst="rect">
+            <a:avLst/>
+          </a:prstGeom>
+          <a:noFill/>
         </p:spPr>
-      </p:pic>
-      <p:sp>
-        <p:nvSpPr>
-          <p:cNvPr id="7" name="Date Placeholder 6"/>
-          <p:cNvSpPr>
-            <a:spLocks noGrp="1"/>
-          </p:cNvSpPr>
-          <p:nvPr>
-            <p:ph type="dt" sz="half" idx="10"/>
-          </p:nvPr>
-        </p:nvSpPr>
-        <p:spPr/>
-        <p:txBody>
-          <a:bodyPr/>
-          <a:lstStyle/>
-          <a:p>
-            <a:r>
-              <a:rPr>
-                <a:latin typeface="Times New Roman"/>
-                <a:cs typeface="Times New Roman"/>
-              </a:rPr>
-              <a:t>20-10-2026</a:t>
+        <p:txBody>
+          <a:bodyPr wrap="square">
+            <a:spAutoFit/>
+          </a:bodyPr>
+          <a:lstStyle/>
+          <a:p>
+            <a:pPr marL="228600" indent="-228600">
+              <a:spcBef>
+                <a:spcPts val="800"/>
+              </a:spcBef>
+              <a:buChar char="•"/>
+            </a:pPr>
+            <a:r>
+              <a:rPr sz="1700">
+                <a:latin typeface="Times New Roman"/>
+                <a:cs typeface="Times New Roman"/>
+              </a:rPr>
+              <a:t>Team-contributed 2026 SMS as a larger real test set</a:t>
+            </a:r>
+          </a:p>
+          <a:p>
+            <a:pPr marL="228600" indent="-228600">
+              <a:spcBef>
+                <a:spcPts val="800"/>
+              </a:spcBef>
+              <a:buChar char="•"/>
+            </a:pPr>
+            <a:r>
+              <a:rPr sz="1700">
+                <a:latin typeface="Times New Roman"/>
+                <a:cs typeface="Times New Roman"/>
+              </a:rPr>
+              <a:t>Second annotator and inter-annotator agreement</a:t>
+            </a:r>
+          </a:p>
+          <a:p>
+            <a:pPr marL="228600" indent="-228600">
+              <a:spcBef>
+                <a:spcPts val="800"/>
+              </a:spcBef>
+              <a:buChar char="•"/>
+            </a:pPr>
+            <a:r>
+              <a:rPr sz="1700">
+                <a:latin typeface="Times New Roman"/>
+                <a:cs typeface="Times New Roman"/>
+              </a:rPr>
+              <a:t>Kannada, Tamil, Telugu and other Indian languages</a:t>
+            </a:r>
+          </a:p>
+          <a:p>
+            <a:pPr marL="228600" indent="-228600">
+              <a:spcBef>
+                <a:spcPts val="800"/>
+              </a:spcBef>
+              <a:buChar char="•"/>
+            </a:pPr>
+            <a:r>
+              <a:rPr sz="1700">
+                <a:latin typeface="Times New Roman"/>
+                <a:cs typeface="Times New Roman"/>
+              </a:rPr>
+              <a:t>Tests against adaptive and LLM-paraphrased scams</a:t>
+            </a:r>
+          </a:p>
+          <a:p>
+            <a:pPr marL="228600" indent="-228600">
+              <a:spcBef>
+                <a:spcPts val="800"/>
+              </a:spcBef>
+              <a:buChar char="•"/>
+            </a:pPr>
+            <a:r>
+              <a:rPr sz="1700">
+                <a:latin typeface="Times New Roman"/>
+                <a:cs typeface="Times New Roman"/>
+              </a:rPr>
+              <a:t>Small transformer models under the same split</a:t>
+            </a:r>
+          </a:p>
+          <a:p>
+            <a:pPr marL="228600" indent="-228600">
+              <a:spcBef>
+                <a:spcPts val="800"/>
+              </a:spcBef>
+              <a:buChar char="•"/>
+            </a:pPr>
+            <a:r>
+              <a:rPr sz="1700">
+                <a:latin typeface="Times New Roman"/>
+                <a:cs typeface="Times New Roman"/>
+              </a:rPr>
+              <a:t>Android share-to-check</a:t>
             </a:r>
           </a:p>
         </p:txBody>
@@ -5702,7 +5630,7 @@
     </p:spTree>
     <p:extLst>
       <p:ext uri="{BB962C8B-B14F-4D97-AF65-F5344CB8AC3E}">
-        <p14:creationId xmlns:p14="http://schemas.microsoft.com/office/powerpoint/2010/main" val="3954442225"/>
+        <p14:creationId xmlns:p14="http://schemas.microsoft.com/office/powerpoint/2010/main" val="586583528"/>
       </p:ext>
     </p:extLst>
   </p:cSld>
@@ -9975,7 +9903,7 @@
                 <a:latin typeface="Times New Roman"/>
                 <a:cs typeface="Times New Roman"/>
               </a:rPr>
-              <a:t>Results: Snapshots of the Output (1/3)</a:t>
+              <a:t>Results: Snapshots of the Output (1/4)</a:t>
             </a:r>
           </a:p>
         </p:txBody>
@@ -10120,7 +10048,7 @@
       </p:sp>
       <p:pic>
         <p:nvPicPr>
-          <p:cNvPr id="8" name="Picture 7" descr="01_landing.jpg"/>
+          <p:cNvPr id="8" name="Picture 7" descr="02_quick_scam.png"/>
           <p:cNvPicPr>
             <a:picLocks noChangeAspect="1"/>
           </p:cNvPicPr>
@@ -10134,8 +10062,8 @@
         </p:blipFill>
         <p:spPr>
           <a:xfrm>
-            <a:off x="2568000" y="1480000"/>
-            <a:ext cx="3328000" cy="2080000"/>
+            <a:off x="356000" y="1900000"/>
+            <a:ext cx="5650000" cy="3531250"/>
           </a:xfrm>
           <a:prstGeom prst="rect">
             <a:avLst/>
@@ -10155,8 +10083,8 @@
         </p:nvSpPr>
         <p:spPr>
           <a:xfrm>
-            <a:off x="2568000" y="3580000"/>
-            <a:ext cx="3328000" cy="400000"/>
+            <a:off x="356000" y="5491250"/>
+            <a:ext cx="5650000" cy="400000"/>
           </a:xfrm>
           <a:prstGeom prst="rect">
             <a:avLst/>
@@ -10176,18 +10104,18 @@
               </a:spcBef>
             </a:pPr>
             <a:r>
-              <a:rPr sz="1300" i="1">
-                <a:latin typeface="Times New Roman"/>
-                <a:cs typeface="Times New Roman"/>
-              </a:rPr>
-              <a:t>Home page with the quick check</a:t>
+              <a:rPr sz="1500" i="1">
+                <a:latin typeface="Times New Roman"/>
+                <a:cs typeface="Times New Roman"/>
+              </a:rPr>
+              <a:t>Quick check: fake KYC SMS flagged as scam</a:t>
             </a:r>
           </a:p>
         </p:txBody>
       </p:sp>
       <p:pic>
         <p:nvPicPr>
-          <p:cNvPr id="10" name="Picture 9" descr="02_quick_scam.jpg"/>
+          <p:cNvPr id="10" name="Picture 9" descr="03_quick_genuine.png"/>
           <p:cNvPicPr>
             <a:picLocks noChangeAspect="1"/>
           </p:cNvPicPr>
@@ -10201,8 +10129,8 @@
         </p:blipFill>
         <p:spPr>
           <a:xfrm>
-            <a:off x="6296000" y="1480000"/>
-            <a:ext cx="3328000" cy="2080000"/>
+            <a:off x="6186000" y="1900000"/>
+            <a:ext cx="5650000" cy="3531250"/>
           </a:xfrm>
           <a:prstGeom prst="rect">
             <a:avLst/>
@@ -10222,8 +10150,8 @@
         </p:nvSpPr>
         <p:spPr>
           <a:xfrm>
-            <a:off x="6296000" y="3580000"/>
-            <a:ext cx="3328000" cy="400000"/>
+            <a:off x="6186000" y="5491250"/>
+            <a:ext cx="5650000" cy="400000"/>
           </a:xfrm>
           <a:prstGeom prst="rect">
             <a:avLst/>
@@ -10243,145 +10171,11 @@
               </a:spcBef>
             </a:pPr>
             <a:r>
-              <a:rPr sz="1300" i="1">
-                <a:latin typeface="Times New Roman"/>
-                <a:cs typeface="Times New Roman"/>
-              </a:rPr>
-              <a:t>Fake KYC SMS flagged as scam</a:t>
-            </a:r>
-          </a:p>
-        </p:txBody>
-      </p:sp>
-      <p:pic>
-        <p:nvPicPr>
-          <p:cNvPr id="12" name="Picture 11" descr="03_quick_genuine.jpg"/>
-          <p:cNvPicPr>
-            <a:picLocks noChangeAspect="1"/>
-          </p:cNvPicPr>
-          <p:nvPr/>
-        </p:nvPicPr>
-        <p:blipFill>
-          <a:blip r:embed="rId5"/>
-          <a:stretch>
-            <a:fillRect/>
-          </a:stretch>
-        </p:blipFill>
-        <p:spPr>
-          <a:xfrm>
-            <a:off x="2568000" y="3930000"/>
-            <a:ext cx="3328000" cy="2080000"/>
-          </a:xfrm>
-          <a:prstGeom prst="rect">
-            <a:avLst/>
-          </a:prstGeom>
-          <a:ln w="9525">
-            <a:solidFill>
-              <a:srgbClr val="9AA0A6"/>
-            </a:solidFill>
-          </a:ln>
-        </p:spPr>
-      </p:pic>
-      <p:sp>
-        <p:nvSpPr>
-          <p:cNvPr id="13" name="TextBox 12"/>
-          <p:cNvSpPr txBox="1"/>
-          <p:nvPr/>
-        </p:nvSpPr>
-        <p:spPr>
-          <a:xfrm>
-            <a:off x="2568000" y="6030000"/>
-            <a:ext cx="3328000" cy="400000"/>
-          </a:xfrm>
-          <a:prstGeom prst="rect">
-            <a:avLst/>
-          </a:prstGeom>
-          <a:noFill/>
-        </p:spPr>
-        <p:txBody>
-          <a:bodyPr wrap="square">
-            <a:spAutoFit/>
-          </a:bodyPr>
-          <a:lstStyle/>
-          <a:p>
-            <a:pPr indent="0" marL="0" algn="ctr">
-              <a:buNone/>
-              <a:spcBef>
-                <a:spcPts val="0"/>
-              </a:spcBef>
-            </a:pPr>
-            <a:r>
-              <a:rPr sz="1300" i="1">
-                <a:latin typeface="Times New Roman"/>
-                <a:cs typeface="Times New Roman"/>
-              </a:rPr>
-              <a:t>Operator 1909 notice: looks genuine</a:t>
-            </a:r>
-          </a:p>
-        </p:txBody>
-      </p:sp>
-      <p:pic>
-        <p:nvPicPr>
-          <p:cNvPr id="14" name="Picture 13" descr="05_analyze_result.jpg"/>
-          <p:cNvPicPr>
-            <a:picLocks noChangeAspect="1"/>
-          </p:cNvPicPr>
-          <p:nvPr/>
-        </p:nvPicPr>
-        <p:blipFill>
-          <a:blip r:embed="rId6"/>
-          <a:stretch>
-            <a:fillRect/>
-          </a:stretch>
-        </p:blipFill>
-        <p:spPr>
-          <a:xfrm>
-            <a:off x="6296000" y="3930000"/>
-            <a:ext cx="3328000" cy="2080000"/>
-          </a:xfrm>
-          <a:prstGeom prst="rect">
-            <a:avLst/>
-          </a:prstGeom>
-          <a:ln w="9525">
-            <a:solidFill>
-              <a:srgbClr val="9AA0A6"/>
-            </a:solidFill>
-          </a:ln>
-        </p:spPr>
-      </p:pic>
-      <p:sp>
-        <p:nvSpPr>
-          <p:cNvPr id="15" name="TextBox 14"/>
-          <p:cNvSpPr txBox="1"/>
-          <p:nvPr/>
-        </p:nvSpPr>
-        <p:spPr>
-          <a:xfrm>
-            <a:off x="6296000" y="6030000"/>
-            <a:ext cx="3328000" cy="400000"/>
-          </a:xfrm>
-          <a:prstGeom prst="rect">
-            <a:avLst/>
-          </a:prstGeom>
-          <a:noFill/>
-        </p:spPr>
-        <p:txBody>
-          <a:bodyPr wrap="square">
-            <a:spAutoFit/>
-          </a:bodyPr>
-          <a:lstStyle/>
-          <a:p>
-            <a:pPr indent="0" marL="0" algn="ctr">
-              <a:buNone/>
-              <a:spcBef>
-                <a:spcPts val="0"/>
-              </a:spcBef>
-            </a:pPr>
-            <a:r>
-              <a:rPr sz="1300" i="1">
-                <a:latin typeface="Times New Roman"/>
-                <a:cs typeface="Times New Roman"/>
-              </a:rPr>
-              <a:t>Full analysis of a scam message</a:t>
+              <a:rPr sz="1500" i="1">
+                <a:latin typeface="Times New Roman"/>
+                <a:cs typeface="Times New Roman"/>
+              </a:rPr>
+              <a:t>Quick check: operator 1909 notice looks genuine</a:t>
             </a:r>
           </a:p>
         </p:txBody>
@@ -10427,7 +10221,7 @@
                 <a:latin typeface="Times New Roman"/>
                 <a:cs typeface="Times New Roman"/>
               </a:rPr>
-              <a:t>Results: Snapshots of the Output (2/3)</a:t>
+              <a:t>Results: Snapshots of the Output (2/4)</a:t>
             </a:r>
           </a:p>
         </p:txBody>
@@ -10572,7 +10366,7 @@
       </p:sp>
       <p:pic>
         <p:nvPicPr>
-          <p:cNvPr id="8" name="Picture 7" descr="06_analyze_xray.jpg"/>
+          <p:cNvPr id="8" name="Picture 7" descr="05_analyze_result.png"/>
           <p:cNvPicPr>
             <a:picLocks noChangeAspect="1"/>
           </p:cNvPicPr>
@@ -10586,8 +10380,8 @@
         </p:blipFill>
         <p:spPr>
           <a:xfrm>
-            <a:off x="2568000" y="1480000"/>
-            <a:ext cx="3328000" cy="2080000"/>
+            <a:off x="356000" y="1900000"/>
+            <a:ext cx="5650000" cy="3531250"/>
           </a:xfrm>
           <a:prstGeom prst="rect">
             <a:avLst/>
@@ -10607,8 +10401,8 @@
         </p:nvSpPr>
         <p:spPr>
           <a:xfrm>
-            <a:off x="2568000" y="3580000"/>
-            <a:ext cx="3328000" cy="400000"/>
+            <a:off x="356000" y="5491250"/>
+            <a:ext cx="5650000" cy="400000"/>
           </a:xfrm>
           <a:prstGeom prst="rect">
             <a:avLst/>
@@ -10628,18 +10422,18 @@
               </a:spcBef>
             </a:pPr>
             <a:r>
-              <a:rPr sz="1300" i="1">
-                <a:latin typeface="Times New Roman"/>
-                <a:cs typeface="Times New Roman"/>
-              </a:rPr>
-              <a:t>Scam X-Ray: risky phrases by stage</a:t>
+              <a:rPr sz="1500" i="1">
+                <a:latin typeface="Times New Roman"/>
+                <a:cs typeface="Times New Roman"/>
+              </a:rPr>
+              <a:t>Full analysis of a scam message</a:t>
             </a:r>
           </a:p>
         </p:txBody>
       </p:sp>
       <p:pic>
         <p:nvPicPr>
-          <p:cNvPr id="10" name="Picture 9" descr="07_analyze_trustlens.jpg"/>
+          <p:cNvPr id="10" name="Picture 9" descr="06_analyze_xray.png"/>
           <p:cNvPicPr>
             <a:picLocks noChangeAspect="1"/>
           </p:cNvPicPr>
@@ -10653,8 +10447,8 @@
         </p:blipFill>
         <p:spPr>
           <a:xfrm>
-            <a:off x="6296000" y="1480000"/>
-            <a:ext cx="3328000" cy="2080000"/>
+            <a:off x="6186000" y="1900000"/>
+            <a:ext cx="5650000" cy="3531250"/>
           </a:xfrm>
           <a:prstGeom prst="rect">
             <a:avLst/>
@@ -10674,8 +10468,8 @@
         </p:nvSpPr>
         <p:spPr>
           <a:xfrm>
-            <a:off x="6296000" y="3580000"/>
-            <a:ext cx="3328000" cy="400000"/>
+            <a:off x="6186000" y="5491250"/>
+            <a:ext cx="5650000" cy="400000"/>
           </a:xfrm>
           <a:prstGeom prst="rect">
             <a:avLst/>
@@ -10695,145 +10489,11 @@
               </a:spcBef>
             </a:pPr>
             <a:r>
-              <a:rPr sz="1300" i="1">
-                <a:latin typeface="Times New Roman"/>
-                <a:cs typeface="Times New Roman"/>
-              </a:rPr>
-              <a:t>TrustLens: scam journey, next steps</a:t>
-            </a:r>
-          </a:p>
-        </p:txBody>
-      </p:sp>
-      <p:pic>
-        <p:nvPicPr>
-          <p:cNvPr id="12" name="Picture 11" descr="08_dashboard.jpg"/>
-          <p:cNvPicPr>
-            <a:picLocks noChangeAspect="1"/>
-          </p:cNvPicPr>
-          <p:nvPr/>
-        </p:nvPicPr>
-        <p:blipFill>
-          <a:blip r:embed="rId5"/>
-          <a:stretch>
-            <a:fillRect/>
-          </a:stretch>
-        </p:blipFill>
-        <p:spPr>
-          <a:xfrm>
-            <a:off x="2568000" y="3930000"/>
-            <a:ext cx="3328000" cy="2080000"/>
-          </a:xfrm>
-          <a:prstGeom prst="rect">
-            <a:avLst/>
-          </a:prstGeom>
-          <a:ln w="9525">
-            <a:solidFill>
-              <a:srgbClr val="9AA0A6"/>
-            </a:solidFill>
-          </a:ln>
-        </p:spPr>
-      </p:pic>
-      <p:sp>
-        <p:nvSpPr>
-          <p:cNvPr id="13" name="TextBox 12"/>
-          <p:cNvSpPr txBox="1"/>
-          <p:nvPr/>
-        </p:nvSpPr>
-        <p:spPr>
-          <a:xfrm>
-            <a:off x="2568000" y="6030000"/>
-            <a:ext cx="3328000" cy="400000"/>
-          </a:xfrm>
-          <a:prstGeom prst="rect">
-            <a:avLst/>
-          </a:prstGeom>
-          <a:noFill/>
-        </p:spPr>
-        <p:txBody>
-          <a:bodyPr wrap="square">
-            <a:spAutoFit/>
-          </a:bodyPr>
-          <a:lstStyle/>
-          <a:p>
-            <a:pPr indent="0" marL="0" algn="ctr">
-              <a:buNone/>
-              <a:spcBef>
-                <a:spcPts val="0"/>
-              </a:spcBef>
-            </a:pPr>
-            <a:r>
-              <a:rPr sz="1300" i="1">
-                <a:latin typeface="Times New Roman"/>
-                <a:cs typeface="Times New Roman"/>
-              </a:rPr>
-              <a:t>Dashboard: priority findings</a:t>
-            </a:r>
-          </a:p>
-        </p:txBody>
-      </p:sp>
-      <p:pic>
-        <p:nvPicPr>
-          <p:cNvPr id="14" name="Picture 13" descr="09_history.jpg"/>
-          <p:cNvPicPr>
-            <a:picLocks noChangeAspect="1"/>
-          </p:cNvPicPr>
-          <p:nvPr/>
-        </p:nvPicPr>
-        <p:blipFill>
-          <a:blip r:embed="rId6"/>
-          <a:stretch>
-            <a:fillRect/>
-          </a:stretch>
-        </p:blipFill>
-        <p:spPr>
-          <a:xfrm>
-            <a:off x="6296000" y="3930000"/>
-            <a:ext cx="3328000" cy="2080000"/>
-          </a:xfrm>
-          <a:prstGeom prst="rect">
-            <a:avLst/>
-          </a:prstGeom>
-          <a:ln w="9525">
-            <a:solidFill>
-              <a:srgbClr val="9AA0A6"/>
-            </a:solidFill>
-          </a:ln>
-        </p:spPr>
-      </p:pic>
-      <p:sp>
-        <p:nvSpPr>
-          <p:cNvPr id="15" name="TextBox 14"/>
-          <p:cNvSpPr txBox="1"/>
-          <p:nvPr/>
-        </p:nvSpPr>
-        <p:spPr>
-          <a:xfrm>
-            <a:off x="6296000" y="6030000"/>
-            <a:ext cx="3328000" cy="400000"/>
-          </a:xfrm>
-          <a:prstGeom prst="rect">
-            <a:avLst/>
-          </a:prstGeom>
-          <a:noFill/>
-        </p:spPr>
-        <p:txBody>
-          <a:bodyPr wrap="square">
-            <a:spAutoFit/>
-          </a:bodyPr>
-          <a:lstStyle/>
-          <a:p>
-            <a:pPr indent="0" marL="0" algn="ctr">
-              <a:buNone/>
-              <a:spcBef>
-                <a:spcPts val="0"/>
-              </a:spcBef>
-            </a:pPr>
-            <a:r>
-              <a:rPr sz="1300" i="1">
-                <a:latin typeface="Times New Roman"/>
-                <a:cs typeface="Times New Roman"/>
-              </a:rPr>
-              <a:t>Scan history with filters and export</a:t>
+              <a:rPr sz="1500" i="1">
+                <a:latin typeface="Times New Roman"/>
+                <a:cs typeface="Times New Roman"/>
+              </a:rPr>
+              <a:t>Scam X-Ray: risky phrases by scam stage</a:t>
             </a:r>
           </a:p>
         </p:txBody>
@@ -10879,7 +10539,7 @@
                 <a:latin typeface="Times New Roman"/>
                 <a:cs typeface="Times New Roman"/>
               </a:rPr>
-              <a:t>Results: Snapshots of the Output (3/3)</a:t>
+              <a:t>Results: Snapshots of the Output (3/4)</a:t>
             </a:r>
           </a:p>
         </p:txBody>
@@ -11024,7 +10684,7 @@
       </p:sp>
       <p:pic>
         <p:nvPicPr>
-          <p:cNvPr id="8" name="Picture 7" descr="10_analytics.jpg"/>
+          <p:cNvPr id="8" name="Picture 7" descr="07_analyze_trustlens.png"/>
           <p:cNvPicPr>
             <a:picLocks noChangeAspect="1"/>
           </p:cNvPicPr>
@@ -11038,8 +10698,8 @@
         </p:blipFill>
         <p:spPr>
           <a:xfrm>
-            <a:off x="2568000" y="1480000"/>
-            <a:ext cx="3328000" cy="2080000"/>
+            <a:off x="356000" y="1900000"/>
+            <a:ext cx="5650000" cy="3531250"/>
           </a:xfrm>
           <a:prstGeom prst="rect">
             <a:avLst/>
@@ -11059,8 +10719,8 @@
         </p:nvSpPr>
         <p:spPr>
           <a:xfrm>
-            <a:off x="2568000" y="3580000"/>
-            <a:ext cx="3328000" cy="400000"/>
+            <a:off x="356000" y="5491250"/>
+            <a:ext cx="5650000" cy="400000"/>
           </a:xfrm>
           <a:prstGeom prst="rect">
             <a:avLst/>
@@ -11080,18 +10740,18 @@
               </a:spcBef>
             </a:pPr>
             <a:r>
-              <a:rPr sz="1300" i="1">
-                <a:latin typeface="Times New Roman"/>
-                <a:cs typeface="Times New Roman"/>
-              </a:rPr>
-              <a:t>Analytics: verdict share, score trend</a:t>
+              <a:rPr sz="1500" i="1">
+                <a:latin typeface="Times New Roman"/>
+                <a:cs typeface="Times New Roman"/>
+              </a:rPr>
+              <a:t>TrustLens: scam journey and next steps</a:t>
             </a:r>
           </a:p>
         </p:txBody>
       </p:sp>
       <p:pic>
         <p:nvPicPr>
-          <p:cNvPr id="10" name="Picture 9" descr="11_tools.jpg"/>
+          <p:cNvPr id="10" name="Picture 9" descr="08_dashboard.png"/>
           <p:cNvPicPr>
             <a:picLocks noChangeAspect="1"/>
           </p:cNvPicPr>
@@ -11105,8 +10765,8 @@
         </p:blipFill>
         <p:spPr>
           <a:xfrm>
-            <a:off x="6296000" y="1480000"/>
-            <a:ext cx="3328000" cy="2080000"/>
+            <a:off x="6186000" y="1900000"/>
+            <a:ext cx="5650000" cy="3531250"/>
           </a:xfrm>
           <a:prstGeom prst="rect">
             <a:avLst/>
@@ -11126,8 +10786,8 @@
         </p:nvSpPr>
         <p:spPr>
           <a:xfrm>
-            <a:off x="6296000" y="3580000"/>
-            <a:ext cx="3328000" cy="400000"/>
+            <a:off x="6186000" y="5491250"/>
+            <a:ext cx="5650000" cy="400000"/>
           </a:xfrm>
           <a:prstGeom prst="rect">
             <a:avLst/>
@@ -11147,33 +10807,217 @@
               </a:spcBef>
             </a:pPr>
             <a:r>
-              <a:rPr sz="1300" i="1">
-                <a:latin typeface="Times New Roman"/>
-                <a:cs typeface="Times New Roman"/>
-              </a:rPr>
-              <a:t>Safety tools: QR, payment, file, chat</a:t>
-            </a:r>
+              <a:rPr sz="1500" i="1">
+                <a:latin typeface="Times New Roman"/>
+                <a:cs typeface="Times New Roman"/>
+              </a:rPr>
+              <a:t>Dashboard: priority findings and recent scans</a:t>
+            </a:r>
+          </a:p>
+        </p:txBody>
+      </p:sp>
+    </p:spTree>
+  </p:cSld>
+  <p:clrMapOvr>
+    <a:masterClrMapping/>
+  </p:clrMapOvr>
+</p:sld>
+</file>
+
+<file path=ppt/slides/slide24.xml><?xml version="1.0" encoding="utf-8"?>
+<p:sld xmlns:a="http://schemas.openxmlformats.org/drawingml/2006/main" xmlns:p="http://schemas.openxmlformats.org/presentationml/2006/main" xmlns:r="http://schemas.openxmlformats.org/officeDocument/2006/relationships">
+  <p:cSld>
+    <p:spTree>
+      <p:nvGrpSpPr>
+        <p:cNvPr id="1" name=""/>
+        <p:cNvGrpSpPr/>
+        <p:nvPr/>
+      </p:nvGrpSpPr>
+      <p:grpSpPr/>
+      <p:sp>
+        <p:nvSpPr>
+          <p:cNvPr id="2" name="Title 1"/>
+          <p:cNvSpPr>
+            <a:spLocks noGrp="1"/>
+          </p:cNvSpPr>
+          <p:nvPr>
+            <p:ph type="title"/>
+          </p:nvPr>
+        </p:nvSpPr>
+        <p:spPr/>
+        <p:txBody>
+          <a:bodyPr/>
+          <a:lstStyle/>
+          <a:p>
+            <a:r>
+              <a:rPr b="1" sz="3200">
+                <a:solidFill>
+                  <a:srgbClr val="1F2A44"/>
+                </a:solidFill>
+                <a:latin typeface="Times New Roman"/>
+                <a:cs typeface="Times New Roman"/>
+              </a:rPr>
+              <a:t>Results: Snapshots of the Output (4/4)</a:t>
+            </a:r>
+          </a:p>
+        </p:txBody>
+      </p:sp>
+      <p:sp>
+        <p:nvSpPr>
+          <p:cNvPr id="4" name="Footer Placeholder 3"/>
+          <p:cNvSpPr>
+            <a:spLocks noGrp="1"/>
+          </p:cNvSpPr>
+          <p:nvPr>
+            <p:ph type="ftr" sz="quarter" idx="11"/>
+          </p:nvPr>
+        </p:nvSpPr>
+        <p:spPr>
+          <a:xfrm>
+            <a:off x="2700000" y="6356350"/>
+            <a:ext cx="6800000" cy="365125"/>
+          </a:xfrm>
+        </p:spPr>
+        <p:txBody>
+          <a:bodyPr/>
+          <a:lstStyle/>
+          <a:p>
+            <a:r>
+              <a:rPr sz="1100">
+                <a:latin typeface="Times New Roman"/>
+                <a:cs typeface="Times New Roman"/>
+              </a:rPr>
+              <a:t>ScamGuard: AI-Based Online Scam and Fraud Detection System   |   Department of CSE, BMSCE</a:t>
+            </a:r>
+          </a:p>
+        </p:txBody>
+      </p:sp>
+      <p:sp>
+        <p:nvSpPr>
+          <p:cNvPr id="5" name="Slide Number Placeholder 4"/>
+          <p:cNvSpPr>
+            <a:spLocks noGrp="1"/>
+          </p:cNvSpPr>
+          <p:nvPr>
+            <p:ph type="sldNum" sz="quarter" idx="12"/>
+          </p:nvPr>
+        </p:nvSpPr>
+        <p:spPr/>
+        <p:txBody>
+          <a:bodyPr/>
+          <a:lstStyle/>
+          <a:p>
+            <a:fld id="{840E0BF8-4B7D-46FA-B28A-DDF089F57DAF}" type="slidenum">
+              <a:rPr lang="en-IN" smtClean="0">
+                <a:latin typeface="Times New Roman"/>
+                <a:cs typeface="Times New Roman"/>
+              </a:rPr>
+              <a:t>6</a:t>
+            </a:fld>
+            <a:endParaRPr lang="en-IN">
+              <a:latin typeface="Times New Roman"/>
+              <a:cs typeface="Times New Roman"/>
+            </a:endParaRPr>
           </a:p>
         </p:txBody>
       </p:sp>
       <p:pic>
         <p:nvPicPr>
-          <p:cNvPr id="12" name="Picture 11" descr="12_simulator.jpg"/>
+          <p:cNvPr id="6" name="Picture 1"/>
           <p:cNvPicPr>
             <a:picLocks noChangeAspect="1"/>
           </p:cNvPicPr>
           <p:nvPr/>
         </p:nvPicPr>
         <p:blipFill>
-          <a:blip r:embed="rId5"/>
+          <a:blip r:embed="rId2">
+            <a:extLst>
+              <a:ext uri="{28A0092B-C50C-407E-A947-70E740481C1C}">
+                <a14:useLocalDpi xmlns:a14="http://schemas.microsoft.com/office/drawing/2010/main" val="0"/>
+              </a:ext>
+            </a:extLst>
+          </a:blip>
+          <a:srcRect/>
+          <a:stretch>
+            <a:fillRect/>
+          </a:stretch>
+        </p:blipFill>
+        <p:spPr bwMode="auto">
+          <a:xfrm>
+            <a:off x="11028362" y="19050"/>
+            <a:ext cx="1163638" cy="1144588"/>
+          </a:xfrm>
+          <a:prstGeom prst="rect">
+            <a:avLst/>
+          </a:prstGeom>
+          <a:noFill/>
+          <a:ln>
+            <a:noFill/>
+          </a:ln>
+          <a:extLst>
+            <a:ext uri="{909E8E84-426E-40DD-AFC4-6F175D3DCCD1}">
+              <a14:hiddenFill xmlns:a14="http://schemas.microsoft.com/office/drawing/2010/main">
+                <a:solidFill>
+                  <a:srgbClr val="FFFFFF"/>
+                </a:solidFill>
+              </a14:hiddenFill>
+            </a:ext>
+            <a:ext uri="{91240B29-F687-4F45-9708-019B960494DF}">
+              <a14:hiddenLine xmlns:a14="http://schemas.microsoft.com/office/drawing/2010/main" w="9525">
+                <a:solidFill>
+                  <a:srgbClr val="000000"/>
+                </a:solidFill>
+                <a:miter lim="800000"/>
+                <a:headEnd/>
+                <a:tailEnd/>
+              </a14:hiddenLine>
+            </a:ext>
+          </a:extLst>
+        </p:spPr>
+      </p:pic>
+      <p:sp>
+        <p:nvSpPr>
+          <p:cNvPr id="7" name="Date Placeholder 6"/>
+          <p:cNvSpPr>
+            <a:spLocks noGrp="1"/>
+          </p:cNvSpPr>
+          <p:nvPr>
+            <p:ph type="dt" sz="half" idx="10"/>
+          </p:nvPr>
+        </p:nvSpPr>
+        <p:spPr/>
+        <p:txBody>
+          <a:bodyPr/>
+          <a:lstStyle/>
+          <a:p>
+            <a:r>
+              <a:rPr>
+                <a:latin typeface="Times New Roman"/>
+                <a:cs typeface="Times New Roman"/>
+              </a:rPr>
+              <a:t>20-10-2026</a:t>
+            </a:r>
+          </a:p>
+        </p:txBody>
+      </p:sp>
+      <p:pic>
+        <p:nvPicPr>
+          <p:cNvPr id="8" name="Picture 7" descr="10_analytics.png"/>
+          <p:cNvPicPr>
+            <a:picLocks noChangeAspect="1"/>
+          </p:cNvPicPr>
+          <p:nvPr/>
+        </p:nvPicPr>
+        <p:blipFill>
+          <a:blip r:embed="rId3"/>
           <a:stretch>
             <a:fillRect/>
           </a:stretch>
         </p:blipFill>
         <p:spPr>
           <a:xfrm>
-            <a:off x="4432000" y="3930000"/>
-            <a:ext cx="3328000" cy="2080000"/>
+            <a:off x="356000" y="1900000"/>
+            <a:ext cx="5650000" cy="3531250"/>
           </a:xfrm>
           <a:prstGeom prst="rect">
             <a:avLst/>
@@ -11187,14 +11031,14 @@
       </p:pic>
       <p:sp>
         <p:nvSpPr>
-          <p:cNvPr id="13" name="TextBox 12"/>
+          <p:cNvPr id="9" name="TextBox 8"/>
           <p:cNvSpPr txBox="1"/>
           <p:nvPr/>
         </p:nvSpPr>
         <p:spPr>
           <a:xfrm>
-            <a:off x="4432000" y="6030000"/>
-            <a:ext cx="3328000" cy="400000"/>
+            <a:off x="356000" y="5491250"/>
+            <a:ext cx="5650000" cy="400000"/>
           </a:xfrm>
           <a:prstGeom prst="rect">
             <a:avLst/>
@@ -11214,11 +11058,78 @@
               </a:spcBef>
             </a:pPr>
             <a:r>
-              <a:rPr sz="1300" i="1">
-                <a:latin typeface="Times New Roman"/>
-                <a:cs typeface="Times New Roman"/>
-              </a:rPr>
-              <a:t>Scam simulator for practice</a:t>
+              <a:rPr sz="1500" i="1">
+                <a:latin typeface="Times New Roman"/>
+                <a:cs typeface="Times New Roman"/>
+              </a:rPr>
+              <a:t>Analytics: verdict share and score trend</a:t>
+            </a:r>
+          </a:p>
+        </p:txBody>
+      </p:sp>
+      <p:pic>
+        <p:nvPicPr>
+          <p:cNvPr id="10" name="Picture 9" descr="11_tools.png"/>
+          <p:cNvPicPr>
+            <a:picLocks noChangeAspect="1"/>
+          </p:cNvPicPr>
+          <p:nvPr/>
+        </p:nvPicPr>
+        <p:blipFill>
+          <a:blip r:embed="rId4"/>
+          <a:stretch>
+            <a:fillRect/>
+          </a:stretch>
+        </p:blipFill>
+        <p:spPr>
+          <a:xfrm>
+            <a:off x="6186000" y="1900000"/>
+            <a:ext cx="5650000" cy="3531250"/>
+          </a:xfrm>
+          <a:prstGeom prst="rect">
+            <a:avLst/>
+          </a:prstGeom>
+          <a:ln w="9525">
+            <a:solidFill>
+              <a:srgbClr val="9AA0A6"/>
+            </a:solidFill>
+          </a:ln>
+        </p:spPr>
+      </p:pic>
+      <p:sp>
+        <p:nvSpPr>
+          <p:cNvPr id="11" name="TextBox 10"/>
+          <p:cNvSpPr txBox="1"/>
+          <p:nvPr/>
+        </p:nvSpPr>
+        <p:spPr>
+          <a:xfrm>
+            <a:off x="6186000" y="5491250"/>
+            <a:ext cx="5650000" cy="400000"/>
+          </a:xfrm>
+          <a:prstGeom prst="rect">
+            <a:avLst/>
+          </a:prstGeom>
+          <a:noFill/>
+        </p:spPr>
+        <p:txBody>
+          <a:bodyPr wrap="square">
+            <a:spAutoFit/>
+          </a:bodyPr>
+          <a:lstStyle/>
+          <a:p>
+            <a:pPr indent="0" marL="0" algn="ctr">
+              <a:buNone/>
+              <a:spcBef>
+                <a:spcPts val="0"/>
+              </a:spcBef>
+            </a:pPr>
+            <a:r>
+              <a:rPr sz="1500" i="1">
+                <a:latin typeface="Times New Roman"/>
+                <a:cs typeface="Times New Roman"/>
+              </a:rPr>
+              <a:t>Safety tools: QR, before-you-pay, file check, chat</a:t>
             </a:r>
           </a:p>
         </p:txBody>

</xml_diff>

<commit_message>
Presentation: snapshots cropped to the content at full resolution
</commit_message>
<xml_diff>
--- a/docs/presentation/ScamGuard_PP2_Presentation.pptx
+++ b/docs/presentation/ScamGuard_PP2_Presentation.pptx
@@ -10062,8 +10062,8 @@
         </p:blipFill>
         <p:spPr>
           <a:xfrm>
-            <a:off x="356000" y="1900000"/>
-            <a:ext cx="5650000" cy="3531250"/>
+            <a:off x="356000" y="1663854"/>
+            <a:ext cx="5650000" cy="3972291"/>
           </a:xfrm>
           <a:prstGeom prst="rect">
             <a:avLst/>
@@ -10083,7 +10083,7 @@
         </p:nvSpPr>
         <p:spPr>
           <a:xfrm>
-            <a:off x="356000" y="5491250"/>
+            <a:off x="356000" y="5730000"/>
             <a:ext cx="5650000" cy="400000"/>
           </a:xfrm>
           <a:prstGeom prst="rect">
@@ -10129,8 +10129,8 @@
         </p:blipFill>
         <p:spPr>
           <a:xfrm>
-            <a:off x="6186000" y="1900000"/>
-            <a:ext cx="5650000" cy="3531250"/>
+            <a:off x="6215706" y="1650000"/>
+            <a:ext cx="5590588" cy="4000000"/>
           </a:xfrm>
           <a:prstGeom prst="rect">
             <a:avLst/>
@@ -10150,7 +10150,7 @@
         </p:nvSpPr>
         <p:spPr>
           <a:xfrm>
-            <a:off x="6186000" y="5491250"/>
+            <a:off x="6186000" y="5730000"/>
             <a:ext cx="5650000" cy="400000"/>
           </a:xfrm>
           <a:prstGeom prst="rect">
@@ -10380,8 +10380,8 @@
         </p:blipFill>
         <p:spPr>
           <a:xfrm>
-            <a:off x="356000" y="1900000"/>
-            <a:ext cx="5650000" cy="3531250"/>
+            <a:off x="356000" y="2105078"/>
+            <a:ext cx="5650000" cy="3089843"/>
           </a:xfrm>
           <a:prstGeom prst="rect">
             <a:avLst/>
@@ -10401,7 +10401,7 @@
         </p:nvSpPr>
         <p:spPr>
           <a:xfrm>
-            <a:off x="356000" y="5491250"/>
+            <a:off x="356000" y="5730000"/>
             <a:ext cx="5650000" cy="400000"/>
           </a:xfrm>
           <a:prstGeom prst="rect">
@@ -10447,8 +10447,8 @@
         </p:blipFill>
         <p:spPr>
           <a:xfrm>
-            <a:off x="6186000" y="1900000"/>
-            <a:ext cx="5650000" cy="3531250"/>
+            <a:off x="6192965" y="1650000"/>
+            <a:ext cx="5636070" cy="4000000"/>
           </a:xfrm>
           <a:prstGeom prst="rect">
             <a:avLst/>
@@ -10468,7 +10468,7 @@
         </p:nvSpPr>
         <p:spPr>
           <a:xfrm>
-            <a:off x="6186000" y="5491250"/>
+            <a:off x="6186000" y="5730000"/>
             <a:ext cx="5650000" cy="400000"/>
           </a:xfrm>
           <a:prstGeom prst="rect">
@@ -10698,8 +10698,8 @@
         </p:blipFill>
         <p:spPr>
           <a:xfrm>
-            <a:off x="356000" y="1900000"/>
-            <a:ext cx="5650000" cy="3531250"/>
+            <a:off x="356000" y="1707812"/>
+            <a:ext cx="5650000" cy="3884375"/>
           </a:xfrm>
           <a:prstGeom prst="rect">
             <a:avLst/>
@@ -10719,7 +10719,7 @@
         </p:nvSpPr>
         <p:spPr>
           <a:xfrm>
-            <a:off x="356000" y="5491250"/>
+            <a:off x="356000" y="5730000"/>
             <a:ext cx="5650000" cy="400000"/>
           </a:xfrm>
           <a:prstGeom prst="rect">
@@ -10765,8 +10765,8 @@
         </p:blipFill>
         <p:spPr>
           <a:xfrm>
-            <a:off x="6186000" y="1900000"/>
-            <a:ext cx="5650000" cy="3531250"/>
+            <a:off x="6186000" y="1778358"/>
+            <a:ext cx="5650000" cy="3743284"/>
           </a:xfrm>
           <a:prstGeom prst="rect">
             <a:avLst/>
@@ -10786,7 +10786,7 @@
         </p:nvSpPr>
         <p:spPr>
           <a:xfrm>
-            <a:off x="6186000" y="5491250"/>
+            <a:off x="6186000" y="5730000"/>
             <a:ext cx="5650000" cy="400000"/>
           </a:xfrm>
           <a:prstGeom prst="rect">
@@ -11016,8 +11016,8 @@
         </p:blipFill>
         <p:spPr>
           <a:xfrm>
-            <a:off x="356000" y="1900000"/>
-            <a:ext cx="5650000" cy="3531250"/>
+            <a:off x="356000" y="2060937"/>
+            <a:ext cx="5650000" cy="3178125"/>
           </a:xfrm>
           <a:prstGeom prst="rect">
             <a:avLst/>
@@ -11037,7 +11037,7 @@
         </p:nvSpPr>
         <p:spPr>
           <a:xfrm>
-            <a:off x="356000" y="5491250"/>
+            <a:off x="356000" y="5730000"/>
             <a:ext cx="5650000" cy="400000"/>
           </a:xfrm>
           <a:prstGeom prst="rect">
@@ -11083,8 +11083,8 @@
         </p:blipFill>
         <p:spPr>
           <a:xfrm>
-            <a:off x="6186000" y="1900000"/>
-            <a:ext cx="5650000" cy="3531250"/>
+            <a:off x="6186000" y="2252024"/>
+            <a:ext cx="5650000" cy="2795951"/>
           </a:xfrm>
           <a:prstGeom prst="rect">
             <a:avLst/>
@@ -11104,7 +11104,7 @@
         </p:nvSpPr>
         <p:spPr>
           <a:xfrm>
-            <a:off x="6186000" y="5491250"/>
+            <a:off x="6186000" y="5730000"/>
             <a:ext cx="5650000" cy="400000"/>
           </a:xfrm>
           <a:prstGeom prst="rect">

</xml_diff>